<commit_message>
Credit Galal (2026) for the Edge-IIoTset placeholder label leak
The report, slides, explainers and website guide no longer claim the
0/0.0 label leak as our finding; it was first reported in
arXiv:2608.15761. The MITM column-shift repair remains ours.

Co-Authored-By: Claude Opus 5.5 <noreply@anthropic.com>
</commit_message>
<xml_diff>
--- a/deliverables/presentation/FL-IDS_Review_Presentation.pptx
+++ b/deliverables/presentation/FL-IDS_Review_Presentation.pptx
@@ -689,7 +689,7 @@
           <a:lstStyle/>
           <a:p>
             <a:r>
-              <a:t>Eight steps from raw data to a blocked attacker. Steps 1 to 3 prepare the data, including fixing two errors we found in the public dataset. Step 4 trains the classifier. Steps 5 and 6 are federated training across ten simulated sites. Step 7 evaluates everything, and step 8 is the live demo.</a:t>
+              <a:t>Eight steps from raw data to a blocked attacker. Steps 1 to 3 prepare the data, including fixing two errors in the public dataset: broken MITM rows we found, and a label leak first reported by Galal. Step 4 trains the classifier. Steps 5 and 6 are federated training across ten simulated sites. Step 7 evaluates everything, and step 8 is the live demo.</a:t>
             </a:r>
           </a:p>
         </p:txBody>
@@ -829,7 +829,7 @@
           <a:lstStyle/>
           <a:p>
             <a:r>
-              <a:t>The dataset is Edge-IIoTset: about two million packets after cleaning, fifteen classes, 71% normal traffic. The classifier is trained on 1.43 million of them and tested on 397 thousand it never saw. The federated part uses a smaller share, about 125 thousand rows, so that the 150 or so experiment runs finish in time. We test strictly, on whole connections never seen in training, and repeat with three seeds. Before any of this we fixed two errors in the public data. One of them was a formatting difference that alone separated normal from attack traffic perfectly, which would have made any model look better than it really is.</a:t>
+              <a:t>The dataset is Edge-IIoTset: about two million packets after cleaning, fifteen classes, 71% normal traffic. The classifier is trained on 1.43 million of them and tested on 397 thousand it never saw. The federated part uses a smaller share, about 125 thousand rows, so that the 150 or so experiment runs finish in time. We test strictly, on whole connections never seen in training, and repeat with three seeds. Before any of this we fixed two errors in the public data. One was a formatting difference that alone separated normal from attack traffic perfectly; Galal reported it first, in August 2026, and we credit that paper. The other, MITM rows stored under the wrong column names, we found and repaired ourselves.</a:t>
             </a:r>
           </a:p>
         </p:txBody>
@@ -1389,7 +1389,7 @@
           <a:lstStyle/>
           <a:p>
             <a:r>
-              <a:t>To conclude: the project is complete. We met the accuracy target with a strict test, the second check catches attacks never seen before, the training resists sabotage up to 40% bad sites, and detections turn into verified blocking rules. We also found and fixed errors in a popular public dataset. Our searches found no published system that combines all five parts, though that is based on targeted searches, not a full systematic review.</a:t>
+              <a:t>To conclude: the project is complete. We met the accuracy target with a strict test, the second check catches attacks never seen before, the training resists sabotage up to 40% bad sites, and detections turn into verified blocking rules. We also found and repaired broken MITM rows in a popular public dataset, and fixed a label leak first reported by Galal. Our searches found no published system that combines all five parts, though that is based on targeted searches, not a full systematic review.</a:t>
             </a:r>
           </a:p>
         </p:txBody>
@@ -6493,7 +6493,7 @@
                   <a:srgbClr val="1B1B1B"/>
                 </a:solidFill>
               </a:rPr>
-              <a:t>label-leak artefact; broken MITM rows</a:t>
+              <a:t>label leak (Galal 2026); broken MITM rows</a:t>
             </a:r>
           </a:p>
         </p:txBody>
@@ -12010,7 +12010,7 @@
             </a:r>
             <a:r>
               <a:rPr sz="1800" b="0"/>
-              <a:t>found and fixed two errors in a widely used public dataset</a:t>
+              <a:t>found and repaired broken MITM rows; fixed a label leak first reported by Galal (2026)</a:t>
             </a:r>
           </a:p>
           <a:p>
@@ -12025,7 +12025,7 @@
             </a:r>
             <a:r>
               <a:rPr sz="1800" b="0"/>
-              <a:t>we found no published system combining all five parts, and the dataset fixes</a:t>
+              <a:t>we found no published system combining all five parts, and the MITM repair</a:t>
             </a:r>
           </a:p>
           <a:p>

</xml_diff>

<commit_message>
Real 20-client run, seeds 43/44, VMware re-host; report and slides updated
- Real 1+20 process Phase A (0.978 recall, 0.0362 FPR) and Phase B on its bundle
- Phase A repeated at seeds 43/44 with 10 and 20 real clients; summary table
- PAPER_NOTES 8.13, website real-run table, report chapter 5 section, 2 slides
- run scripts, configs, logs, small run records and bundles

Co-Authored-By: Claude Sonnet 5.5 <noreply@anthropic.com>
</commit_message>
<xml_diff>
--- a/deliverables/presentation/FL-IDS_Review_Presentation.pptx
+++ b/deliverables/presentation/FL-IDS_Review_Presentation.pptx
@@ -26,7 +26,9 @@
     <p:sldId id="281" r:id="rId29"/>
     <p:sldId id="280" r:id="rId28"/>
     <p:sldId id="279" r:id="rId27"/>
+    <p:sldId id="284" r:id="rId4"/>
     <p:sldId id="278" r:id="rId26"/>
+    <p:sldId id="285" r:id="rId32"/>
     <p:sldId id="271" r:id="rId12"/>
     <p:sldId id="270" r:id="rId13"/>
     <p:sldId id="272" r:id="rId14"/>
@@ -1600,6 +1602,146 @@
           <a:p>
             <a:r>
               <a:t>Thank you. We're happy to take questions.</a:t>
+            </a:r>
+          </a:p>
+        </p:txBody>
+      </p:sp>
+      <p:sp>
+        <p:nvSpPr>
+          <p:cNvPr id="4" name="Slide Number Placeholder 3"/>
+          <p:cNvSpPr>
+            <a:spLocks noGrp="1"/>
+          </p:cNvSpPr>
+          <p:nvPr>
+            <p:ph type="sldNum" idx="5" sz="quarter"/>
+          </p:nvPr>
+        </p:nvSpPr>
+        <p:spPr/>
+      </p:sp>
+    </p:spTree>
+  </p:cSld>
+  <p:clrMapOvr>
+    <a:masterClrMapping/>
+  </p:clrMapOvr>
+</p:notes>
+</file>
+
+<file path=ppt/notesSlides/notesSlide24.xml><?xml version="1.0" encoding="utf-8"?>
+<p:notes xmlns:a="http://schemas.openxmlformats.org/drawingml/2006/main" xmlns:p="http://schemas.openxmlformats.org/presentationml/2006/main" xmlns:r="http://schemas.openxmlformats.org/officeDocument/2006/relationships">
+  <p:cSld>
+    <p:spTree>
+      <p:nvGrpSpPr>
+        <p:cNvPr id="1" name=""/>
+        <p:cNvGrpSpPr/>
+        <p:nvPr/>
+      </p:nvGrpSpPr>
+      <p:grpSpPr>
+        <a:xfrm>
+          <a:off x="0" y="0"/>
+          <a:ext cx="0" cy="0"/>
+          <a:chOff x="0" y="0"/>
+          <a:chExt cx="0" cy="0"/>
+        </a:xfrm>
+      </p:grpSpPr>
+      <p:sp>
+        <p:nvSpPr>
+          <p:cNvPr id="2" name="Slide Image Placeholder 1"/>
+          <p:cNvSpPr>
+            <a:spLocks noGrp="1"/>
+          </p:cNvSpPr>
+          <p:nvPr>
+            <p:ph type="sldImg" idx="2"/>
+          </p:nvPr>
+        </p:nvSpPr>
+        <p:spPr/>
+      </p:sp>
+      <p:sp>
+        <p:nvSpPr>
+          <p:cNvPr id="3" name="Notes Placeholder 2"/>
+          <p:cNvSpPr>
+            <a:spLocks noGrp="1"/>
+          </p:cNvSpPr>
+          <p:nvPr>
+            <p:ph type="body" idx="3" sz="quarter"/>
+          </p:nvPr>
+        </p:nvSpPr>
+        <p:spPr/>
+        <p:txBody>
+          <a:bodyPr/>
+          <a:lstStyle/>
+          <a:p>
+            <a:r>
+              <a:t>Earlier we only had a one-process simulation of 20 sites. We now ran the real thing: one server and 20 separate client programs, on a virtual machine with enough memory. We repeated it with three different random seeds for both 10 and 20 sites. Attack detection stays very high; one 20-site run at seed 42 is lower at 0.978, and we have not yet found out why. Only three seeds, so we do not claim confidence intervals.</a:t>
+            </a:r>
+          </a:p>
+        </p:txBody>
+      </p:sp>
+      <p:sp>
+        <p:nvSpPr>
+          <p:cNvPr id="4" name="Slide Number Placeholder 3"/>
+          <p:cNvSpPr>
+            <a:spLocks noGrp="1"/>
+          </p:cNvSpPr>
+          <p:nvPr>
+            <p:ph type="sldNum" idx="5" sz="quarter"/>
+          </p:nvPr>
+        </p:nvSpPr>
+        <p:spPr/>
+      </p:sp>
+    </p:spTree>
+  </p:cSld>
+  <p:clrMapOvr>
+    <a:masterClrMapping/>
+  </p:clrMapOvr>
+</p:notes>
+</file>
+
+<file path=ppt/notesSlides/notesSlide25.xml><?xml version="1.0" encoding="utf-8"?>
+<p:notes xmlns:a="http://schemas.openxmlformats.org/drawingml/2006/main" xmlns:p="http://schemas.openxmlformats.org/presentationml/2006/main" xmlns:r="http://schemas.openxmlformats.org/officeDocument/2006/relationships">
+  <p:cSld>
+    <p:spTree>
+      <p:nvGrpSpPr>
+        <p:cNvPr id="1" name=""/>
+        <p:cNvGrpSpPr/>
+        <p:nvPr/>
+      </p:nvGrpSpPr>
+      <p:grpSpPr>
+        <a:xfrm>
+          <a:off x="0" y="0"/>
+          <a:ext cx="0" cy="0"/>
+          <a:chOff x="0" y="0"/>
+          <a:chExt cx="0" cy="0"/>
+        </a:xfrm>
+      </p:grpSpPr>
+      <p:sp>
+        <p:nvSpPr>
+          <p:cNvPr id="2" name="Slide Image Placeholder 1"/>
+          <p:cNvSpPr>
+            <a:spLocks noGrp="1"/>
+          </p:cNvSpPr>
+          <p:nvPr>
+            <p:ph type="sldImg" idx="2"/>
+          </p:nvPr>
+        </p:nvSpPr>
+        <p:spPr/>
+      </p:sp>
+      <p:sp>
+        <p:nvSpPr>
+          <p:cNvPr id="3" name="Notes Placeholder 2"/>
+          <p:cNvSpPr>
+            <a:spLocks noGrp="1"/>
+          </p:cNvSpPr>
+          <p:nvPr>
+            <p:ph type="body" idx="3" sz="quarter"/>
+          </p:nvPr>
+        </p:nvSpPr>
+        <p:spPr/>
+        <p:txBody>
+          <a:bodyPr/>
+          <a:lstStyle/>
+          <a:p>
+            <a:r>
+              <a:t>This is one complete run on 10 sites with the data features already prepared. The shared model takes a few minutes to train. Afterwards the live part, replaying the attack, classifying it and installing the drop rule, takes seconds.</a:t>
             </a:r>
           </a:p>
         </p:txBody>
@@ -13171,6 +13313,456 @@
         <p14:creationId xmlns:p14="http://schemas.microsoft.com/office/powerpoint/2010/main" val="3778863572"/>
       </p:ext>
     </p:extLst>
+  </p:cSld>
+  <p:clrMapOvr>
+    <a:masterClrMapping/>
+  </p:clrMapOvr>
+</p:sld>
+</file>
+
+<file path=ppt/slides/slide25.xml><?xml version="1.0" encoding="utf-8"?>
+<p:sld xmlns:a="http://schemas.openxmlformats.org/drawingml/2006/main" xmlns:p="http://schemas.openxmlformats.org/presentationml/2006/main" xmlns:r="http://schemas.openxmlformats.org/officeDocument/2006/relationships">
+  <p:cSld>
+    <p:spTree>
+      <p:nvGrpSpPr>
+        <p:cNvPr id="1" name=""/>
+        <p:cNvGrpSpPr/>
+        <p:nvPr/>
+      </p:nvGrpSpPr>
+      <p:grpSpPr/>
+      <p:sp>
+        <p:nvSpPr>
+          <p:cNvPr id="2" name="Title 1"/>
+          <p:cNvSpPr>
+            <a:spLocks noGrp="1"/>
+          </p:cNvSpPr>
+          <p:nvPr>
+            <p:ph type="title"/>
+          </p:nvPr>
+        </p:nvSpPr>
+        <p:spPr/>
+        <p:txBody>
+          <a:bodyPr/>
+          <a:lstStyle/>
+          <a:p>
+            <a:r>
+              <a:rPr lang="en-US" dirty="0"/>
+              <a:t>Results: Scaling Up and Repeating</a:t>
+            </a:r>
+            <a:endParaRPr lang="en-IN" dirty="0"/>
+          </a:p>
+        </p:txBody>
+      </p:sp>
+      <p:sp>
+        <p:nvSpPr>
+          <p:cNvPr id="4" name="Footer Placeholder 3"/>
+          <p:cNvSpPr>
+            <a:spLocks noGrp="1"/>
+          </p:cNvSpPr>
+          <p:nvPr>
+            <p:ph type="ftr" sz="quarter" idx="11"/>
+          </p:nvPr>
+        </p:nvSpPr>
+        <p:spPr/>
+        <p:txBody>
+          <a:bodyPr/>
+          <a:lstStyle/>
+          <a:p>
+            <a:r>
+              <a:rPr lang="en-IN"/>
+              <a:t>FL-IDS                         Department of CSE, BMSCE</a:t>
+            </a:r>
+          </a:p>
+        </p:txBody>
+      </p:sp>
+      <p:sp>
+        <p:nvSpPr>
+          <p:cNvPr id="5" name="Slide Number Placeholder 4"/>
+          <p:cNvSpPr>
+            <a:spLocks noGrp="1"/>
+          </p:cNvSpPr>
+          <p:nvPr>
+            <p:ph type="sldNum" sz="quarter" idx="12"/>
+          </p:nvPr>
+        </p:nvSpPr>
+        <p:spPr/>
+        <p:txBody>
+          <a:bodyPr/>
+          <a:lstStyle/>
+          <a:p>
+            <a:fld id="{840E0BF8-4B7D-46FA-B28A-DDF089F57DAF}" type="slidenum">
+              <a:rPr lang="en-IN" smtClean="0"/>
+              <a:t>10</a:t>
+            </a:fld>
+            <a:endParaRPr lang="en-IN"/>
+          </a:p>
+        </p:txBody>
+      </p:sp>
+      <p:pic>
+        <p:nvPicPr>
+          <p:cNvPr id="6" name="Picture 5" descr="image.jpeg"/>
+          <p:cNvPicPr>
+            <a:picLocks noChangeAspect="1"/>
+          </p:cNvPicPr>
+          <p:nvPr/>
+        </p:nvPicPr>
+        <p:blipFill>
+          <a:blip r:embed="rId2"/>
+          <a:stretch>
+            <a:fillRect/>
+          </a:stretch>
+        </p:blipFill>
+        <p:spPr>
+          <a:xfrm>
+            <a:off x="11028362" y="19050"/>
+            <a:ext cx="1163638" cy="1144588"/>
+          </a:xfrm>
+          <a:prstGeom prst="rect">
+            <a:avLst/>
+          </a:prstGeom>
+        </p:spPr>
+      </p:pic>
+      <p:sp>
+        <p:nvSpPr>
+          <p:cNvPr id="7" name="Date Placeholder 6"/>
+          <p:cNvSpPr>
+            <a:spLocks noGrp="1"/>
+          </p:cNvSpPr>
+          <p:nvPr>
+            <p:ph type="dt" sz="half" idx="10"/>
+          </p:nvPr>
+        </p:nvSpPr>
+        <p:spPr/>
+        <p:txBody>
+          <a:bodyPr/>
+          <a:lstStyle/>
+          <a:p>
+            <a:r>
+              <a:rPr lang="en-IN"/>
+              <a:t>16-10-2026</a:t>
+            </a:r>
+          </a:p>
+        </p:txBody>
+      </p:sp>
+      <p:pic>
+        <p:nvPicPr>
+          <p:cNvPr id="8" name="Picture 7" descr="image.png"/>
+          <p:cNvPicPr>
+            <a:picLocks noChangeAspect="1"/>
+          </p:cNvPicPr>
+          <p:nvPr/>
+        </p:nvPicPr>
+        <p:blipFill>
+          <a:blip r:embed="rId3"/>
+          <a:stretch>
+            <a:fillRect/>
+          </a:stretch>
+        </p:blipFill>
+        <p:spPr>
+          <a:xfrm>
+            <a:off x="2036068" y="1540688"/>
+            <a:ext cx="8119863" cy="3000000"/>
+          </a:xfrm>
+          <a:prstGeom prst="rect">
+            <a:avLst/>
+          </a:prstGeom>
+        </p:spPr>
+      </p:pic>
+      <p:sp>
+        <p:nvSpPr>
+          <p:cNvPr id="9" name="Rounded Rectangle 8"/>
+          <p:cNvSpPr/>
+          <p:nvPr/>
+        </p:nvSpPr>
+        <p:spPr>
+          <a:xfrm>
+            <a:off x="838200" y="4640688"/>
+            <a:ext cx="10515600" cy="1250000"/>
+          </a:xfrm>
+          <a:prstGeom prst="roundRect">
+            <a:avLst>
+              <a:gd name="adj" fmla="val 6000"/>
+            </a:avLst>
+          </a:prstGeom>
+          <a:solidFill>
+            <a:srgbClr val="F1F2F4"/>
+          </a:solidFill>
+          <a:ln>
+            <a:noFill/>
+          </a:ln>
+          <a:effectLst/>
+        </p:spPr>
+        <p:style>
+          <a:lnRef idx="1">
+            <a:schemeClr val="accent1"/>
+          </a:lnRef>
+          <a:fillRef idx="3">
+            <a:schemeClr val="accent1"/>
+          </a:fillRef>
+          <a:effectRef idx="2">
+            <a:schemeClr val="accent1"/>
+          </a:effectRef>
+          <a:fontRef idx="minor">
+            <a:schemeClr val="lt1"/>
+          </a:fontRef>
+        </p:style>
+        <p:txBody>
+          <a:bodyPr rtlCol="0" anchor="t" wrap="square" lIns="150000" rIns="150000" tIns="120000"/>
+          <a:lstStyle/>
+          <a:p>
+            <a:pPr algn="l"/>
+            <a:r>
+              <a:rPr sz="1500" b="1">
+                <a:solidFill>
+                  <a:srgbClr val="1E2761"/>
+                </a:solidFill>
+              </a:rPr>
+              <a:t>What it shows</a:t>
+            </a:r>
+          </a:p>
+          <a:p>
+            <a:pPr algn="l">
+              <a:spcBef>
+                <a:spcPts val="500"/>
+              </a:spcBef>
+            </a:pPr>
+            <a:r>
+              <a:rPr sz="1400" b="0">
+                <a:solidFill>
+                  <a:srgbClr val="1B1B1B"/>
+                </a:solidFill>
+              </a:rPr>
+              <a:t>Real runs, not a simulation: 10 and 20 separate client processes, three seeds each. Attacks caught on average: 0.998 with 10 sites and 0.992 with 20; false alarms stay at 2.8–4.0%. One 20-site run (seed 42) dips to 0.978 and is not yet explained.</a:t>
+            </a:r>
+          </a:p>
+        </p:txBody>
+      </p:sp>
+    </p:spTree>
+  </p:cSld>
+  <p:clrMapOvr>
+    <a:masterClrMapping/>
+  </p:clrMapOvr>
+</p:sld>
+</file>
+
+<file path=ppt/slides/slide26.xml><?xml version="1.0" encoding="utf-8"?>
+<p:sld xmlns:a="http://schemas.openxmlformats.org/drawingml/2006/main" xmlns:p="http://schemas.openxmlformats.org/presentationml/2006/main" xmlns:r="http://schemas.openxmlformats.org/officeDocument/2006/relationships">
+  <p:cSld>
+    <p:spTree>
+      <p:nvGrpSpPr>
+        <p:cNvPr id="1" name=""/>
+        <p:cNvGrpSpPr/>
+        <p:nvPr/>
+      </p:nvGrpSpPr>
+      <p:grpSpPr/>
+      <p:sp>
+        <p:nvSpPr>
+          <p:cNvPr id="2" name="Title 1"/>
+          <p:cNvSpPr>
+            <a:spLocks noGrp="1"/>
+          </p:cNvSpPr>
+          <p:nvPr>
+            <p:ph type="title"/>
+          </p:nvPr>
+        </p:nvSpPr>
+        <p:spPr/>
+        <p:txBody>
+          <a:bodyPr/>
+          <a:lstStyle/>
+          <a:p>
+            <a:r>
+              <a:rPr lang="en-US" dirty="0"/>
+              <a:t>Results: One Whole Run, Timed</a:t>
+            </a:r>
+            <a:endParaRPr lang="en-IN" dirty="0"/>
+          </a:p>
+        </p:txBody>
+      </p:sp>
+      <p:sp>
+        <p:nvSpPr>
+          <p:cNvPr id="4" name="Footer Placeholder 3"/>
+          <p:cNvSpPr>
+            <a:spLocks noGrp="1"/>
+          </p:cNvSpPr>
+          <p:nvPr>
+            <p:ph type="ftr" sz="quarter" idx="11"/>
+          </p:nvPr>
+        </p:nvSpPr>
+        <p:spPr/>
+        <p:txBody>
+          <a:bodyPr/>
+          <a:lstStyle/>
+          <a:p>
+            <a:r>
+              <a:rPr lang="en-IN"/>
+              <a:t>FL-IDS                         Department of CSE, BMSCE</a:t>
+            </a:r>
+          </a:p>
+        </p:txBody>
+      </p:sp>
+      <p:sp>
+        <p:nvSpPr>
+          <p:cNvPr id="5" name="Slide Number Placeholder 4"/>
+          <p:cNvSpPr>
+            <a:spLocks noGrp="1"/>
+          </p:cNvSpPr>
+          <p:nvPr>
+            <p:ph type="sldNum" sz="quarter" idx="12"/>
+          </p:nvPr>
+        </p:nvSpPr>
+        <p:spPr/>
+        <p:txBody>
+          <a:bodyPr/>
+          <a:lstStyle/>
+          <a:p>
+            <a:fld id="{840E0BF8-4B7D-46FA-B28A-DDF089F57DAF}" type="slidenum">
+              <a:rPr lang="en-IN" smtClean="0"/>
+              <a:t>10</a:t>
+            </a:fld>
+            <a:endParaRPr lang="en-IN"/>
+          </a:p>
+        </p:txBody>
+      </p:sp>
+      <p:pic>
+        <p:nvPicPr>
+          <p:cNvPr id="6" name="Picture 5" descr="image.jpeg"/>
+          <p:cNvPicPr>
+            <a:picLocks noChangeAspect="1"/>
+          </p:cNvPicPr>
+          <p:nvPr/>
+        </p:nvPicPr>
+        <p:blipFill>
+          <a:blip r:embed="rId2"/>
+          <a:stretch>
+            <a:fillRect/>
+          </a:stretch>
+        </p:blipFill>
+        <p:spPr>
+          <a:xfrm>
+            <a:off x="11028362" y="19050"/>
+            <a:ext cx="1163638" cy="1144588"/>
+          </a:xfrm>
+          <a:prstGeom prst="rect">
+            <a:avLst/>
+          </a:prstGeom>
+        </p:spPr>
+      </p:pic>
+      <p:sp>
+        <p:nvSpPr>
+          <p:cNvPr id="7" name="Date Placeholder 6"/>
+          <p:cNvSpPr>
+            <a:spLocks noGrp="1"/>
+          </p:cNvSpPr>
+          <p:nvPr>
+            <p:ph type="dt" sz="half" idx="10"/>
+          </p:nvPr>
+        </p:nvSpPr>
+        <p:spPr/>
+        <p:txBody>
+          <a:bodyPr/>
+          <a:lstStyle/>
+          <a:p>
+            <a:r>
+              <a:rPr lang="en-IN"/>
+              <a:t>16-10-2026</a:t>
+            </a:r>
+          </a:p>
+        </p:txBody>
+      </p:sp>
+      <p:pic>
+        <p:nvPicPr>
+          <p:cNvPr id="8" name="Picture 7" descr="image.png"/>
+          <p:cNvPicPr>
+            <a:picLocks noChangeAspect="1"/>
+          </p:cNvPicPr>
+          <p:nvPr/>
+        </p:nvPicPr>
+        <p:blipFill>
+          <a:blip r:embed="rId3"/>
+          <a:stretch>
+            <a:fillRect/>
+          </a:stretch>
+        </p:blipFill>
+        <p:spPr>
+          <a:xfrm>
+            <a:off x="2036068" y="1540688"/>
+            <a:ext cx="8119863" cy="3000000"/>
+          </a:xfrm>
+          <a:prstGeom prst="rect">
+            <a:avLst/>
+          </a:prstGeom>
+        </p:spPr>
+      </p:pic>
+      <p:sp>
+        <p:nvSpPr>
+          <p:cNvPr id="9" name="Rounded Rectangle 8"/>
+          <p:cNvSpPr/>
+          <p:nvPr/>
+        </p:nvSpPr>
+        <p:spPr>
+          <a:xfrm>
+            <a:off x="838200" y="4640688"/>
+            <a:ext cx="10515600" cy="1250000"/>
+          </a:xfrm>
+          <a:prstGeom prst="roundRect">
+            <a:avLst>
+              <a:gd name="adj" fmla="val 6000"/>
+            </a:avLst>
+          </a:prstGeom>
+          <a:solidFill>
+            <a:srgbClr val="F1F2F4"/>
+          </a:solidFill>
+          <a:ln>
+            <a:noFill/>
+          </a:ln>
+          <a:effectLst/>
+        </p:spPr>
+        <p:style>
+          <a:lnRef idx="1">
+            <a:schemeClr val="accent1"/>
+          </a:lnRef>
+          <a:fillRef idx="3">
+            <a:schemeClr val="accent1"/>
+          </a:fillRef>
+          <a:effectRef idx="2">
+            <a:schemeClr val="accent1"/>
+          </a:effectRef>
+          <a:fontRef idx="minor">
+            <a:schemeClr val="lt1"/>
+          </a:fontRef>
+        </p:style>
+        <p:txBody>
+          <a:bodyPr rtlCol="0" anchor="t" wrap="square" lIns="150000" rIns="150000" tIns="120000"/>
+          <a:lstStyle/>
+          <a:p>
+            <a:pPr algn="l"/>
+            <a:r>
+              <a:rPr sz="1500" b="1">
+                <a:solidFill>
+                  <a:srgbClr val="1E2761"/>
+                </a:solidFill>
+              </a:rPr>
+              <a:t>What it shows</a:t>
+            </a:r>
+          </a:p>
+          <a:p>
+            <a:pPr algn="l">
+              <a:spcBef>
+                <a:spcPts val="500"/>
+              </a:spcBef>
+            </a:pPr>
+            <a:r>
+              <a:rPr sz="1400" b="0">
+                <a:solidFill>
+                  <a:srgbClr val="1B1B1B"/>
+                </a:solidFill>
+              </a:rPr>
+              <a:t>A complete run, from raw data to a block rule on the switch, took about 219 seconds. Training the shared model is almost all of it; once a model exists, spotting and blocking an attack takes seconds.</a:t>
+            </a:r>
+          </a:p>
+        </p:txBody>
+      </p:sp>
+    </p:spTree>
   </p:cSld>
   <p:clrMapOvr>
     <a:masterClrMapping/>

</xml_diff>

<commit_message>
Follow-ups: seeds 43/44, adaptive attacker, pruning, time-ordered split, figures, report and deck
- Ablation, poisoning sweep and zero-day at seeds 43 and 44, run as 40 parallel shards (VM resized to 20 vCPUs / 48 GB)
- StealthAttackerClient (white-box adaptive attacker) and its evaluation; weight pruning (post-training and during FL); clip comparison
- Per-class breakdown of the 20-client run, real runs with attackers, Phase B on the seed bundles, time-ordered split, single-feature AUROC
- PAPER_NOTES 8.14 and 12.2, results page 7c, report chapter 5 section, new slide, regenerated explainers, seven new figures
- 236 tests pass, 2 skipped

Co-Authored-By: Claude Sonnet 5.5 <noreply@anthropic.com>
</commit_message>
<xml_diff>
--- a/deliverables/presentation/FL-IDS_Review_Presentation.pptx
+++ b/deliverables/presentation/FL-IDS_Review_Presentation.pptx
@@ -29,6 +29,7 @@
     <p:sldId id="284" r:id="rId4"/>
     <p:sldId id="278" r:id="rId26"/>
     <p:sldId id="285" r:id="rId32"/>
+    <p:sldId id="286" r:id="rId33"/>
     <p:sldId id="271" r:id="rId12"/>
     <p:sldId id="270" r:id="rId13"/>
     <p:sldId id="272" r:id="rId14"/>
@@ -1742,6 +1743,76 @@
           <a:p>
             <a:r>
               <a:t>This is one complete run on 10 sites with the data features already prepared. The shared model takes a few minutes to train. Afterwards the live part, replaying the attack, classifying it and installing the drop rule, takes seconds.</a:t>
+            </a:r>
+          </a:p>
+        </p:txBody>
+      </p:sp>
+      <p:sp>
+        <p:nvSpPr>
+          <p:cNvPr id="4" name="Slide Number Placeholder 3"/>
+          <p:cNvSpPr>
+            <a:spLocks noGrp="1"/>
+          </p:cNvSpPr>
+          <p:nvPr>
+            <p:ph type="sldNum" idx="5" sz="quarter"/>
+          </p:nvPr>
+        </p:nvSpPr>
+        <p:spPr/>
+      </p:sp>
+    </p:spTree>
+  </p:cSld>
+  <p:clrMapOvr>
+    <a:masterClrMapping/>
+  </p:clrMapOvr>
+</p:notes>
+</file>
+
+<file path=ppt/notesSlides/notesSlide26.xml><?xml version="1.0" encoding="utf-8"?>
+<p:notes xmlns:a="http://schemas.openxmlformats.org/drawingml/2006/main" xmlns:p="http://schemas.openxmlformats.org/presentationml/2006/main" xmlns:r="http://schemas.openxmlformats.org/officeDocument/2006/relationships">
+  <p:cSld>
+    <p:spTree>
+      <p:nvGrpSpPr>
+        <p:cNvPr id="1" name=""/>
+        <p:cNvGrpSpPr/>
+        <p:nvPr/>
+      </p:nvGrpSpPr>
+      <p:grpSpPr>
+        <a:xfrm>
+          <a:off x="0" y="0"/>
+          <a:ext cx="0" cy="0"/>
+          <a:chOff x="0" y="0"/>
+          <a:chExt cx="0" cy="0"/>
+        </a:xfrm>
+      </p:grpSpPr>
+      <p:sp>
+        <p:nvSpPr>
+          <p:cNvPr id="2" name="Slide Image Placeholder 1"/>
+          <p:cNvSpPr>
+            <a:spLocks noGrp="1"/>
+          </p:cNvSpPr>
+          <p:nvPr>
+            <p:ph type="sldImg" idx="2"/>
+          </p:nvPr>
+        </p:nvSpPr>
+        <p:spPr/>
+      </p:sp>
+      <p:sp>
+        <p:nvSpPr>
+          <p:cNvPr id="3" name="Notes Placeholder 2"/>
+          <p:cNvSpPr>
+            <a:spLocks noGrp="1"/>
+          </p:cNvSpPr>
+          <p:nvPr>
+            <p:ph type="body" idx="3" sz="quarter"/>
+          </p:nvPr>
+        </p:nvSpPr>
+        <p:spPr/>
+        <p:txBody>
+          <a:bodyPr/>
+          <a:lstStyle/>
+          <a:p>
+            <a:r>
+              <a:t>Three follow-ups. First, weight pruning, which was one of our objectives: pruned while the shared model trains, 70 percent of the weights can go and the backstop barely changes; pruned afterwards it collapses. Second, a smarter attacker that knows how our filter works: it gets through most of the time, which is a real weakness, although the first-stage classifier still catches known attacks. Third, we repeated the big experiments with two more seeds and the conclusions held. Limits: single seed for pruning and the smart attacker, and we did not test new-attack detection against the smart attacker.</a:t>
             </a:r>
           </a:p>
         </p:txBody>
@@ -10742,7 +10813,7 @@
 </file>
 
 <file path=ppt/slides/slide19.xml><?xml version="1.0" encoding="utf-8"?>
-<p:sld xmlns:a="http://schemas.openxmlformats.org/drawingml/2006/main" xmlns:r="http://schemas.openxmlformats.org/officeDocument/2006/relationships" xmlns:p="http://schemas.openxmlformats.org/presentationml/2006/main">
+<p:sld xmlns:a="http://schemas.openxmlformats.org/drawingml/2006/main" xmlns:p="http://schemas.openxmlformats.org/presentationml/2006/main" xmlns:r="http://schemas.openxmlformats.org/officeDocument/2006/relationships">
   <p:cSld>
     <p:spTree>
       <p:nvGrpSpPr>
@@ -10750,14 +10821,7 @@
         <p:cNvGrpSpPr/>
         <p:nvPr/>
       </p:nvGrpSpPr>
-      <p:grpSpPr>
-        <a:xfrm>
-          <a:off x="0" y="0"/>
-          <a:ext cx="0" cy="0"/>
-          <a:chOff x="0" y="0"/>
-          <a:chExt cx="0" cy="0"/>
-        </a:xfrm>
-      </p:grpSpPr>
+      <p:grpSpPr/>
       <p:sp>
         <p:nvSpPr>
           <p:cNvPr id="2" name="Title 1"/>
@@ -10775,7 +10839,7 @@
           <a:p>
             <a:r>
               <a:rPr lang="en-US" dirty="0"/>
-              <a:t>Results: Live Demo (Detect and Block)</a:t>
+              <a:t>Results: Scaling Up and Repeating</a:t>
             </a:r>
             <a:endParaRPr lang="en-IN" dirty="0"/>
           </a:p>
@@ -10828,26 +10892,19 @@
       </p:sp>
       <p:pic>
         <p:nvPicPr>
-          <p:cNvPr id="6" name="Picture 1"/>
+          <p:cNvPr id="6" name="Picture 5" descr="image.jpeg"/>
           <p:cNvPicPr>
             <a:picLocks noChangeAspect="1"/>
           </p:cNvPicPr>
           <p:nvPr/>
         </p:nvPicPr>
         <p:blipFill>
-          <a:blip r:embed="rId2">
-            <a:extLst>
-              <a:ext uri="{28A0092B-C50C-407E-A947-70E740481C1C}">
-                <a14:useLocalDpi xmlns:a14="http://schemas.microsoft.com/office/drawing/2010/main" val="0"/>
-              </a:ext>
-            </a:extLst>
-          </a:blip>
-          <a:srcRect/>
+          <a:blip r:embed="rId2"/>
           <a:stretch>
             <a:fillRect/>
           </a:stretch>
         </p:blipFill>
-        <p:spPr bwMode="auto">
+        <p:spPr>
           <a:xfrm>
             <a:off x="11028362" y="19050"/>
             <a:ext cx="1163638" cy="1144588"/>
@@ -10855,29 +10912,6 @@
           <a:prstGeom prst="rect">
             <a:avLst/>
           </a:prstGeom>
-          <a:noFill/>
-          <a:ln>
-            <a:noFill/>
-          </a:ln>
-          <a:extLst>
-            <a:ext uri="{909E8E84-426E-40DD-AFC4-6F175D3DCCD1}">
-              <a14:hiddenFill xmlns:a14="http://schemas.microsoft.com/office/drawing/2010/main">
-                <a:solidFill>
-                  <a:srgbClr val="FFFFFF"/>
-                </a:solidFill>
-              </a14:hiddenFill>
-            </a:ext>
-            <a:ext uri="{91240B29-F687-4F45-9708-019B960494DF}">
-              <a14:hiddenLine xmlns:a14="http://schemas.microsoft.com/office/drawing/2010/main" w="9525">
-                <a:solidFill>
-                  <a:srgbClr val="000000"/>
-                </a:solidFill>
-                <a:miter lim="800000"/>
-                <a:headEnd/>
-                <a:tailEnd/>
-              </a14:hiddenLine>
-            </a:ext>
-          </a:extLst>
         </p:spPr>
       </p:pic>
       <p:sp>
@@ -10902,16 +10936,40 @@
           </a:p>
         </p:txBody>
       </p:sp>
-      <p:sp>
-        <p:nvSpPr>
-          <p:cNvPr id="8" name="Rounded Rectangle 7"/>
+      <p:pic>
+        <p:nvPicPr>
+          <p:cNvPr id="8" name="Picture 7" descr="image.png"/>
+          <p:cNvPicPr>
+            <a:picLocks noChangeAspect="1"/>
+          </p:cNvPicPr>
+          <p:nvPr/>
+        </p:nvPicPr>
+        <p:blipFill>
+          <a:blip r:embed="rId3"/>
+          <a:stretch>
+            <a:fillRect/>
+          </a:stretch>
+        </p:blipFill>
+        <p:spPr>
+          <a:xfrm>
+            <a:off x="2036068" y="1540688"/>
+            <a:ext cx="8119863" cy="3000000"/>
+          </a:xfrm>
+          <a:prstGeom prst="rect">
+            <a:avLst/>
+          </a:prstGeom>
+        </p:spPr>
+      </p:pic>
+      <p:sp>
+        <p:nvSpPr>
+          <p:cNvPr id="9" name="Rounded Rectangle 8"/>
           <p:cNvSpPr/>
           <p:nvPr/>
         </p:nvSpPr>
         <p:spPr>
           <a:xfrm>
-            <a:off x="838200" y="1740688"/>
-            <a:ext cx="2463900" cy="1900000"/>
+            <a:off x="838200" y="4640688"/>
+            <a:ext cx="10515600" cy="1250000"/>
           </a:xfrm>
           <a:prstGeom prst="roundRect">
             <a:avLst>
@@ -10946,12 +11004,12 @@
           <a:p>
             <a:pPr algn="l"/>
             <a:r>
-              <a:rPr sz="1600" b="1">
-                <a:solidFill>
-                  <a:srgbClr val="5B6770"/>
-                </a:solidFill>
-              </a:rPr>
-              <a:t> </a:t>
+              <a:rPr sz="1500" b="1">
+                <a:solidFill>
+                  <a:srgbClr val="1E2761"/>
+                </a:solidFill>
+              </a:rPr>
+              <a:t>What it shows</a:t>
             </a:r>
           </a:p>
           <a:p>
@@ -10966,779 +11024,12 @@
                   <a:srgbClr val="1B1B1B"/>
                 </a:solidFill>
               </a:rPr>
-              <a:t>real Backdoor attack capture, 24,914 packets, into the emulated network</a:t>
-            </a:r>
-          </a:p>
-        </p:txBody>
-      </p:sp>
-      <p:sp>
-        <p:nvSpPr>
-          <p:cNvPr id="9" name="TextBox 8"/>
-          <p:cNvSpPr txBox="1"/>
-          <p:nvPr/>
-        </p:nvSpPr>
-        <p:spPr>
-          <a:xfrm>
-            <a:off x="1418200" y="1810688"/>
-            <a:ext cx="1783900" cy="450000"/>
-          </a:xfrm>
-          <a:prstGeom prst="rect">
-            <a:avLst/>
-          </a:prstGeom>
-          <a:noFill/>
-        </p:spPr>
-        <p:txBody>
-          <a:bodyPr wrap="square" anchor="ctr" lIns="0" rIns="0">
-            <a:spAutoFit/>
-          </a:bodyPr>
-          <a:lstStyle/>
-          <a:p>
-            <a:pPr algn="l"/>
-            <a:r>
-              <a:rPr sz="1600" b="1">
-                <a:solidFill>
-                  <a:srgbClr val="5B6770"/>
-                </a:solidFill>
-              </a:rPr>
-              <a:t>Replay</a:t>
-            </a:r>
-          </a:p>
-        </p:txBody>
-      </p:sp>
-      <p:sp>
-        <p:nvSpPr>
-          <p:cNvPr id="10" name="Oval 9"/>
-          <p:cNvSpPr/>
-          <p:nvPr/>
-        </p:nvSpPr>
-        <p:spPr>
-          <a:xfrm>
-            <a:off x="948200" y="1835688"/>
-            <a:ext cx="380000" cy="380000"/>
-          </a:xfrm>
-          <a:prstGeom prst="ellipse">
-            <a:avLst/>
-          </a:prstGeom>
-          <a:solidFill>
-            <a:srgbClr val="5B6770"/>
-          </a:solidFill>
-          <a:ln>
-            <a:noFill/>
-          </a:ln>
-          <a:effectLst/>
-        </p:spPr>
-        <p:style>
-          <a:lnRef idx="1">
-            <a:schemeClr val="accent1"/>
-          </a:lnRef>
-          <a:fillRef idx="3">
-            <a:schemeClr val="accent1"/>
-          </a:fillRef>
-          <a:effectRef idx="2">
-            <a:schemeClr val="accent1"/>
-          </a:effectRef>
-          <a:fontRef idx="minor">
-            <a:schemeClr val="lt1"/>
-          </a:fontRef>
-        </p:style>
-        <p:txBody>
-          <a:bodyPr rtlCol="0" anchor="ctr" lIns="0" rIns="0" tIns="0" bIns="0"/>
-          <a:lstStyle/>
-          <a:p>
-            <a:pPr algn="ctr"/>
-            <a:r>
-              <a:rPr sz="1300" b="1">
-                <a:solidFill>
-                  <a:srgbClr val="FFFFFF"/>
-                </a:solidFill>
-              </a:rPr>
-              <a:t>1</a:t>
-            </a:r>
-          </a:p>
-        </p:txBody>
-      </p:sp>
-      <p:cxnSp>
-        <p:nvCxnSpPr>
-          <p:cNvPr id="11" name="Connector 10"/>
-          <p:cNvCxnSpPr/>
-          <p:nvPr/>
-        </p:nvCxnSpPr>
-        <p:spPr>
-          <a:xfrm>
-            <a:off x="3312100" y="2690688"/>
-            <a:ext cx="200000" cy="0"/>
-          </a:xfrm>
-          <a:prstGeom prst="line">
-            <a:avLst/>
-          </a:prstGeom>
-          <a:ln w="25400">
-            <a:solidFill>
-              <a:srgbClr val="5B6770"/>
-            </a:solidFill>
-            <a:tailEnd type="triangle" w="med" len="med"/>
-          </a:ln>
-        </p:spPr>
-        <p:style>
-          <a:lnRef idx="2">
-            <a:schemeClr val="accent1"/>
-          </a:lnRef>
-          <a:fillRef idx="0">
-            <a:schemeClr val="accent1"/>
-          </a:fillRef>
-          <a:effectRef idx="1">
-            <a:schemeClr val="accent1"/>
-          </a:effectRef>
-          <a:fontRef idx="minor">
-            <a:schemeClr val="tx1"/>
-          </a:fontRef>
-        </p:style>
-      </p:cxnSp>
-      <p:sp>
-        <p:nvSpPr>
-          <p:cNvPr id="12" name="Rounded Rectangle 11"/>
-          <p:cNvSpPr/>
-          <p:nvPr/>
-        </p:nvSpPr>
-        <p:spPr>
-          <a:xfrm>
-            <a:off x="3522100" y="1740688"/>
-            <a:ext cx="2463900" cy="1900000"/>
-          </a:xfrm>
-          <a:prstGeom prst="roundRect">
-            <a:avLst>
-              <a:gd name="adj" fmla="val 6000"/>
-            </a:avLst>
-          </a:prstGeom>
-          <a:solidFill>
-            <a:srgbClr val="E3E7F4"/>
-          </a:solidFill>
-          <a:ln>
-            <a:noFill/>
-          </a:ln>
-          <a:effectLst/>
-        </p:spPr>
-        <p:style>
-          <a:lnRef idx="1">
-            <a:schemeClr val="accent1"/>
-          </a:lnRef>
-          <a:fillRef idx="3">
-            <a:schemeClr val="accent1"/>
-          </a:fillRef>
-          <a:effectRef idx="2">
-            <a:schemeClr val="accent1"/>
-          </a:effectRef>
-          <a:fontRef idx="minor">
-            <a:schemeClr val="lt1"/>
-          </a:fontRef>
-        </p:style>
-        <p:txBody>
-          <a:bodyPr rtlCol="0" anchor="t" wrap="square" lIns="150000" rIns="150000" tIns="120000"/>
-          <a:lstStyle/>
-          <a:p>
-            <a:pPr algn="l"/>
-            <a:r>
-              <a:rPr sz="1600" b="1">
-                <a:solidFill>
-                  <a:srgbClr val="1E2761"/>
-                </a:solidFill>
-              </a:rPr>
-              <a:t> </a:t>
-            </a:r>
-          </a:p>
-          <a:p>
-            <a:pPr algn="l">
-              <a:spcBef>
-                <a:spcPts val="500"/>
-              </a:spcBef>
-            </a:pPr>
-            <a:r>
-              <a:rPr sz="1400" b="0">
-                <a:solidFill>
-                  <a:srgbClr val="1B1B1B"/>
-                </a:solidFill>
-              </a:rPr>
-              <a:t>classified as Backdoor with 99.7% confidence</a:t>
-            </a:r>
-          </a:p>
-        </p:txBody>
-      </p:sp>
-      <p:sp>
-        <p:nvSpPr>
-          <p:cNvPr id="13" name="TextBox 12"/>
-          <p:cNvSpPr txBox="1"/>
-          <p:nvPr/>
-        </p:nvSpPr>
-        <p:spPr>
-          <a:xfrm>
-            <a:off x="4102100" y="1810688"/>
-            <a:ext cx="1783900" cy="450000"/>
-          </a:xfrm>
-          <a:prstGeom prst="rect">
-            <a:avLst/>
-          </a:prstGeom>
-          <a:noFill/>
-        </p:spPr>
-        <p:txBody>
-          <a:bodyPr wrap="square" anchor="ctr" lIns="0" rIns="0">
-            <a:spAutoFit/>
-          </a:bodyPr>
-          <a:lstStyle/>
-          <a:p>
-            <a:pPr algn="l"/>
-            <a:r>
-              <a:rPr sz="1600" b="1">
-                <a:solidFill>
-                  <a:srgbClr val="1E2761"/>
-                </a:solidFill>
-              </a:rPr>
-              <a:t>Detect</a:t>
-            </a:r>
-          </a:p>
-        </p:txBody>
-      </p:sp>
-      <p:sp>
-        <p:nvSpPr>
-          <p:cNvPr id="14" name="Oval 13"/>
-          <p:cNvSpPr/>
-          <p:nvPr/>
-        </p:nvSpPr>
-        <p:spPr>
-          <a:xfrm>
-            <a:off x="3632100" y="1835688"/>
-            <a:ext cx="380000" cy="380000"/>
-          </a:xfrm>
-          <a:prstGeom prst="ellipse">
-            <a:avLst/>
-          </a:prstGeom>
-          <a:solidFill>
-            <a:srgbClr val="1E2761"/>
-          </a:solidFill>
-          <a:ln>
-            <a:noFill/>
-          </a:ln>
-          <a:effectLst/>
-        </p:spPr>
-        <p:style>
-          <a:lnRef idx="1">
-            <a:schemeClr val="accent1"/>
-          </a:lnRef>
-          <a:fillRef idx="3">
-            <a:schemeClr val="accent1"/>
-          </a:fillRef>
-          <a:effectRef idx="2">
-            <a:schemeClr val="accent1"/>
-          </a:effectRef>
-          <a:fontRef idx="minor">
-            <a:schemeClr val="lt1"/>
-          </a:fontRef>
-        </p:style>
-        <p:txBody>
-          <a:bodyPr rtlCol="0" anchor="ctr" lIns="0" rIns="0" tIns="0" bIns="0"/>
-          <a:lstStyle/>
-          <a:p>
-            <a:pPr algn="ctr"/>
-            <a:r>
-              <a:rPr sz="1300" b="1">
-                <a:solidFill>
-                  <a:srgbClr val="FFFFFF"/>
-                </a:solidFill>
-              </a:rPr>
-              <a:t>2</a:t>
-            </a:r>
-          </a:p>
-        </p:txBody>
-      </p:sp>
-      <p:cxnSp>
-        <p:nvCxnSpPr>
-          <p:cNvPr id="15" name="Connector 14"/>
-          <p:cNvCxnSpPr/>
-          <p:nvPr/>
-        </p:nvCxnSpPr>
-        <p:spPr>
-          <a:xfrm>
-            <a:off x="5996000" y="2690688"/>
-            <a:ext cx="200000" cy="0"/>
-          </a:xfrm>
-          <a:prstGeom prst="line">
-            <a:avLst/>
-          </a:prstGeom>
-          <a:ln w="25400">
-            <a:solidFill>
-              <a:srgbClr val="5B6770"/>
-            </a:solidFill>
-            <a:tailEnd type="triangle" w="med" len="med"/>
-          </a:ln>
-        </p:spPr>
-        <p:style>
-          <a:lnRef idx="2">
-            <a:schemeClr val="accent1"/>
-          </a:lnRef>
-          <a:fillRef idx="0">
-            <a:schemeClr val="accent1"/>
-          </a:fillRef>
-          <a:effectRef idx="1">
-            <a:schemeClr val="accent1"/>
-          </a:effectRef>
-          <a:fontRef idx="minor">
-            <a:schemeClr val="tx1"/>
-          </a:fontRef>
-        </p:style>
-      </p:cxnSp>
-      <p:sp>
-        <p:nvSpPr>
-          <p:cNvPr id="16" name="Rounded Rectangle 15"/>
-          <p:cNvSpPr/>
-          <p:nvPr/>
-        </p:nvSpPr>
-        <p:spPr>
-          <a:xfrm>
-            <a:off x="6206000" y="1740688"/>
-            <a:ext cx="2463900" cy="1900000"/>
-          </a:xfrm>
-          <a:prstGeom prst="roundRect">
-            <a:avLst>
-              <a:gd name="adj" fmla="val 6000"/>
-            </a:avLst>
-          </a:prstGeom>
-          <a:solidFill>
-            <a:srgbClr val="FBF0D9"/>
-          </a:solidFill>
-          <a:ln>
-            <a:noFill/>
-          </a:ln>
-          <a:effectLst/>
-        </p:spPr>
-        <p:style>
-          <a:lnRef idx="1">
-            <a:schemeClr val="accent1"/>
-          </a:lnRef>
-          <a:fillRef idx="3">
-            <a:schemeClr val="accent1"/>
-          </a:fillRef>
-          <a:effectRef idx="2">
-            <a:schemeClr val="accent1"/>
-          </a:effectRef>
-          <a:fontRef idx="minor">
-            <a:schemeClr val="lt1"/>
-          </a:fontRef>
-        </p:style>
-        <p:txBody>
-          <a:bodyPr rtlCol="0" anchor="t" wrap="square" lIns="150000" rIns="150000" tIns="120000"/>
-          <a:lstStyle/>
-          <a:p>
-            <a:pPr algn="l"/>
-            <a:r>
-              <a:rPr sz="1600" b="1">
-                <a:solidFill>
-                  <a:srgbClr val="C98A0B"/>
-                </a:solidFill>
-              </a:rPr>
-              <a:t> </a:t>
-            </a:r>
-          </a:p>
-          <a:p>
-            <a:pPr algn="l">
-              <a:spcBef>
-                <a:spcPts val="500"/>
-              </a:spcBef>
-            </a:pPr>
-            <a:r>
-              <a:rPr sz="1400" b="0">
-                <a:solidFill>
-                  <a:srgbClr val="1B1B1B"/>
-                </a:solidFill>
-              </a:rPr>
-              <a:t>confidence ≥ 85% → block</a:t>
-            </a:r>
-          </a:p>
-        </p:txBody>
-      </p:sp>
-      <p:sp>
-        <p:nvSpPr>
-          <p:cNvPr id="17" name="TextBox 16"/>
-          <p:cNvSpPr txBox="1"/>
-          <p:nvPr/>
-        </p:nvSpPr>
-        <p:spPr>
-          <a:xfrm>
-            <a:off x="6786000" y="1810688"/>
-            <a:ext cx="1783900" cy="450000"/>
-          </a:xfrm>
-          <a:prstGeom prst="rect">
-            <a:avLst/>
-          </a:prstGeom>
-          <a:noFill/>
-        </p:spPr>
-        <p:txBody>
-          <a:bodyPr wrap="square" anchor="ctr" lIns="0" rIns="0">
-            <a:spAutoFit/>
-          </a:bodyPr>
-          <a:lstStyle/>
-          <a:p>
-            <a:pPr algn="l"/>
-            <a:r>
-              <a:rPr sz="1600" b="1">
-                <a:solidFill>
-                  <a:srgbClr val="C98A0B"/>
-                </a:solidFill>
-              </a:rPr>
-              <a:t>Decide</a:t>
-            </a:r>
-          </a:p>
-        </p:txBody>
-      </p:sp>
-      <p:sp>
-        <p:nvSpPr>
-          <p:cNvPr id="18" name="Oval 17"/>
-          <p:cNvSpPr/>
-          <p:nvPr/>
-        </p:nvSpPr>
-        <p:spPr>
-          <a:xfrm>
-            <a:off x="6316000" y="1835688"/>
-            <a:ext cx="380000" cy="380000"/>
-          </a:xfrm>
-          <a:prstGeom prst="ellipse">
-            <a:avLst/>
-          </a:prstGeom>
-          <a:solidFill>
-            <a:srgbClr val="C98A0B"/>
-          </a:solidFill>
-          <a:ln>
-            <a:noFill/>
-          </a:ln>
-          <a:effectLst/>
-        </p:spPr>
-        <p:style>
-          <a:lnRef idx="1">
-            <a:schemeClr val="accent1"/>
-          </a:lnRef>
-          <a:fillRef idx="3">
-            <a:schemeClr val="accent1"/>
-          </a:fillRef>
-          <a:effectRef idx="2">
-            <a:schemeClr val="accent1"/>
-          </a:effectRef>
-          <a:fontRef idx="minor">
-            <a:schemeClr val="lt1"/>
-          </a:fontRef>
-        </p:style>
-        <p:txBody>
-          <a:bodyPr rtlCol="0" anchor="ctr" lIns="0" rIns="0" tIns="0" bIns="0"/>
-          <a:lstStyle/>
-          <a:p>
-            <a:pPr algn="ctr"/>
-            <a:r>
-              <a:rPr sz="1300" b="1">
-                <a:solidFill>
-                  <a:srgbClr val="FFFFFF"/>
-                </a:solidFill>
-              </a:rPr>
-              <a:t>3</a:t>
-            </a:r>
-          </a:p>
-        </p:txBody>
-      </p:sp>
-      <p:cxnSp>
-        <p:nvCxnSpPr>
-          <p:cNvPr id="19" name="Connector 18"/>
-          <p:cNvCxnSpPr/>
-          <p:nvPr/>
-        </p:nvCxnSpPr>
-        <p:spPr>
-          <a:xfrm>
-            <a:off x="8679900" y="2690688"/>
-            <a:ext cx="200000" cy="0"/>
-          </a:xfrm>
-          <a:prstGeom prst="line">
-            <a:avLst/>
-          </a:prstGeom>
-          <a:ln w="25400">
-            <a:solidFill>
-              <a:srgbClr val="5B6770"/>
-            </a:solidFill>
-            <a:tailEnd type="triangle" w="med" len="med"/>
-          </a:ln>
-        </p:spPr>
-        <p:style>
-          <a:lnRef idx="2">
-            <a:schemeClr val="accent1"/>
-          </a:lnRef>
-          <a:fillRef idx="0">
-            <a:schemeClr val="accent1"/>
-          </a:fillRef>
-          <a:effectRef idx="1">
-            <a:schemeClr val="accent1"/>
-          </a:effectRef>
-          <a:fontRef idx="minor">
-            <a:schemeClr val="tx1"/>
-          </a:fontRef>
-        </p:style>
-      </p:cxnSp>
-      <p:sp>
-        <p:nvSpPr>
-          <p:cNvPr id="20" name="Rounded Rectangle 19"/>
-          <p:cNvSpPr/>
-          <p:nvPr/>
-        </p:nvSpPr>
-        <p:spPr>
-          <a:xfrm>
-            <a:off x="8889900" y="1740688"/>
-            <a:ext cx="2463900" cy="1900000"/>
-          </a:xfrm>
-          <a:prstGeom prst="roundRect">
-            <a:avLst>
-              <a:gd name="adj" fmla="val 6000"/>
-            </a:avLst>
-          </a:prstGeom>
-          <a:solidFill>
-            <a:srgbClr val="F9E1E3"/>
-          </a:solidFill>
-          <a:ln>
-            <a:noFill/>
-          </a:ln>
-          <a:effectLst/>
-        </p:spPr>
-        <p:style>
-          <a:lnRef idx="1">
-            <a:schemeClr val="accent1"/>
-          </a:lnRef>
-          <a:fillRef idx="3">
-            <a:schemeClr val="accent1"/>
-          </a:fillRef>
-          <a:effectRef idx="2">
-            <a:schemeClr val="accent1"/>
-          </a:effectRef>
-          <a:fontRef idx="minor">
-            <a:schemeClr val="lt1"/>
-          </a:fontRef>
-        </p:style>
-        <p:txBody>
-          <a:bodyPr rtlCol="0" anchor="t" wrap="square" lIns="150000" rIns="150000" tIns="120000"/>
-          <a:lstStyle/>
-          <a:p>
-            <a:pPr algn="l"/>
-            <a:r>
-              <a:rPr sz="1600" b="1">
-                <a:solidFill>
-                  <a:srgbClr val="D64550"/>
-                </a:solidFill>
-              </a:rPr>
-              <a:t> </a:t>
-            </a:r>
-          </a:p>
-          <a:p>
-            <a:pPr algn="l">
-              <a:spcBef>
-                <a:spcPts val="500"/>
-              </a:spcBef>
-            </a:pPr>
-            <a:r>
-              <a:rPr sz="1400" b="0">
-                <a:solidFill>
-                  <a:srgbClr val="1B1B1B"/>
-                </a:solidFill>
-              </a:rPr>
-              <a:t>drop rule installed on the switch and read back to confirm</a:t>
-            </a:r>
-          </a:p>
-        </p:txBody>
-      </p:sp>
-      <p:sp>
-        <p:nvSpPr>
-          <p:cNvPr id="21" name="TextBox 20"/>
-          <p:cNvSpPr txBox="1"/>
-          <p:nvPr/>
-        </p:nvSpPr>
-        <p:spPr>
-          <a:xfrm>
-            <a:off x="9469900" y="1810688"/>
-            <a:ext cx="1783900" cy="450000"/>
-          </a:xfrm>
-          <a:prstGeom prst="rect">
-            <a:avLst/>
-          </a:prstGeom>
-          <a:noFill/>
-        </p:spPr>
-        <p:txBody>
-          <a:bodyPr wrap="square" anchor="ctr" lIns="0" rIns="0">
-            <a:spAutoFit/>
-          </a:bodyPr>
-          <a:lstStyle/>
-          <a:p>
-            <a:pPr algn="l"/>
-            <a:r>
-              <a:rPr sz="1600" b="1">
-                <a:solidFill>
-                  <a:srgbClr val="D64550"/>
-                </a:solidFill>
-              </a:rPr>
-              <a:t>Block</a:t>
-            </a:r>
-          </a:p>
-        </p:txBody>
-      </p:sp>
-      <p:sp>
-        <p:nvSpPr>
-          <p:cNvPr id="22" name="Oval 21"/>
-          <p:cNvSpPr/>
-          <p:nvPr/>
-        </p:nvSpPr>
-        <p:spPr>
-          <a:xfrm>
-            <a:off x="8999900" y="1835688"/>
-            <a:ext cx="380000" cy="380000"/>
-          </a:xfrm>
-          <a:prstGeom prst="ellipse">
-            <a:avLst/>
-          </a:prstGeom>
-          <a:solidFill>
-            <a:srgbClr val="D64550"/>
-          </a:solidFill>
-          <a:ln>
-            <a:noFill/>
-          </a:ln>
-          <a:effectLst/>
-        </p:spPr>
-        <p:style>
-          <a:lnRef idx="1">
-            <a:schemeClr val="accent1"/>
-          </a:lnRef>
-          <a:fillRef idx="3">
-            <a:schemeClr val="accent1"/>
-          </a:fillRef>
-          <a:effectRef idx="2">
-            <a:schemeClr val="accent1"/>
-          </a:effectRef>
-          <a:fontRef idx="minor">
-            <a:schemeClr val="lt1"/>
-          </a:fontRef>
-        </p:style>
-        <p:txBody>
-          <a:bodyPr rtlCol="0" anchor="ctr" lIns="0" rIns="0" tIns="0" bIns="0"/>
-          <a:lstStyle/>
-          <a:p>
-            <a:pPr algn="ctr"/>
-            <a:r>
-              <a:rPr sz="1300" b="1">
-                <a:solidFill>
-                  <a:srgbClr val="FFFFFF"/>
-                </a:solidFill>
-              </a:rPr>
-              <a:t>4</a:t>
-            </a:r>
-          </a:p>
-        </p:txBody>
-      </p:sp>
-      <p:sp>
-        <p:nvSpPr>
-          <p:cNvPr id="23" name="Rounded Rectangle 22"/>
-          <p:cNvSpPr/>
-          <p:nvPr/>
-        </p:nvSpPr>
-        <p:spPr>
-          <a:xfrm>
-            <a:off x="838200" y="3890688"/>
-            <a:ext cx="10515600" cy="900000"/>
-          </a:xfrm>
-          <a:prstGeom prst="roundRect">
-            <a:avLst>
-              <a:gd name="adj" fmla="val 6000"/>
-            </a:avLst>
-          </a:prstGeom>
-          <a:solidFill>
-            <a:srgbClr val="F1F2F4"/>
-          </a:solidFill>
-          <a:ln>
-            <a:noFill/>
-          </a:ln>
-          <a:effectLst/>
-        </p:spPr>
-        <p:style>
-          <a:lnRef idx="1">
-            <a:schemeClr val="accent1"/>
-          </a:lnRef>
-          <a:fillRef idx="3">
-            <a:schemeClr val="accent1"/>
-          </a:fillRef>
-          <a:effectRef idx="2">
-            <a:schemeClr val="accent1"/>
-          </a:effectRef>
-          <a:fontRef idx="minor">
-            <a:schemeClr val="lt1"/>
-          </a:fontRef>
-        </p:style>
-        <p:txBody>
-          <a:bodyPr rtlCol="0" anchor="t" wrap="square" lIns="150000" rIns="150000" tIns="120000"/>
-          <a:lstStyle/>
-          <a:p>
-            <a:pPr algn="l"/>
-            <a:r>
-              <a:rPr sz="1500" b="1">
-                <a:solidFill>
-                  <a:srgbClr val="D64550"/>
-                </a:solidFill>
-              </a:rPr>
-              <a:t>Rule on the switch</a:t>
-            </a:r>
-          </a:p>
-          <a:p>
-            <a:pPr algn="l">
-              <a:spcBef>
-                <a:spcPts val="500"/>
-              </a:spcBef>
-            </a:pPr>
-            <a:r>
-              <a:rPr sz="1600" b="0">
-                <a:solidFill>
-                  <a:srgbClr val="1B1B1B"/>
-                </a:solidFill>
-              </a:rPr>
-              <a:t>priority=100, ip, nw_src=10.0.0.1  actions=drop</a:t>
-            </a:r>
-          </a:p>
-        </p:txBody>
-      </p:sp>
-      <p:sp>
-        <p:nvSpPr>
-          <p:cNvPr id="24" name="TextBox 23"/>
-          <p:cNvSpPr txBox="1"/>
-          <p:nvPr/>
-        </p:nvSpPr>
-        <p:spPr>
-          <a:xfrm>
-            <a:off x="838200" y="4940688"/>
-            <a:ext cx="10515600" cy="900000"/>
-          </a:xfrm>
-          <a:prstGeom prst="rect">
-            <a:avLst/>
-          </a:prstGeom>
-          <a:noFill/>
-        </p:spPr>
-        <p:txBody>
-          <a:bodyPr wrap="square" anchor="t" lIns="0" rIns="0">
-            <a:spAutoFit/>
-          </a:bodyPr>
-          <a:lstStyle/>
-          <a:p>
-            <a:pPr algn="l"/>
-            <a:r>
-              <a:rPr sz="1400" b="0">
-                <a:solidFill>
-                  <a:srgbClr val="5B6770"/>
-                </a:solidFill>
-              </a:rPr>
-              <a:t>Real 10-site federated run: 0.999 attack detection (was 0.889), 3.5% false alarms. 24,669 of 24,914 packets flagged.  Limitation: the decision is made after the capture is analysed, not packet by packet.</a:t>
+              <a:t>Real runs, not a simulation: 10 and 20 separate client processes, three seeds each. Attacks caught on average: 0.998 with 10 sites and 0.992 with 20; false alarms stay at 2.8–4.0%. One 20-site run (seed 42) dips to 0.978 and is not yet explained.</a:t>
             </a:r>
           </a:p>
         </p:txBody>
       </p:sp>
     </p:spTree>
-    <p:extLst>
-      <p:ext uri="{BB962C8B-B14F-4D97-AF65-F5344CB8AC3E}">
-        <p14:creationId xmlns:p14="http://schemas.microsoft.com/office/powerpoint/2010/main" val="339988347"/>
-      </p:ext>
-    </p:extLst>
   </p:cSld>
   <p:clrMapOvr>
     <a:masterClrMapping/>
@@ -12044,146 +11335,10 @@
           <a:lstStyle/>
           <a:p>
             <a:r>
-              <a:rPr lang="en-IN" dirty="0"/>
-              <a:t>Conclusion</a:t>
-            </a:r>
-          </a:p>
-        </p:txBody>
-      </p:sp>
-      <p:sp>
-        <p:nvSpPr>
-          <p:cNvPr id="3" name="Content Placeholder 2"/>
-          <p:cNvSpPr>
-            <a:spLocks noGrp="1"/>
-          </p:cNvSpPr>
-          <p:nvPr>
-            <p:ph idx="1"/>
-          </p:nvPr>
-        </p:nvSpPr>
-        <p:spPr/>
-        <p:txBody>
-          <a:bodyPr wrap="square"/>
-          <a:lstStyle/>
-          <a:p>
-            <a:pPr>
-              <a:spcAft>
-                <a:spcPts val="800"/>
-              </a:spcAft>
-            </a:pPr>
-            <a:r>
-              <a:rPr sz="1800" b="1"/>
-              <a:t>Accuracy target met: </a:t>
-            </a:r>
-            <a:r>
-              <a:rPr sz="1800" b="0"/>
-              <a:t>99.7% accuracy and 0.983 macro F1 on 397k unseen packets (was 96.4% / 0.889)</a:t>
-            </a:r>
-            <a:endParaRPr lang="en-IN"/>
-          </a:p>
-          <a:p>
-            <a:pPr>
-              <a:spcAft>
-                <a:spcPts val="800"/>
-              </a:spcAft>
-            </a:pPr>
-            <a:r>
-              <a:rPr sz="1800" b="1"/>
-              <a:t>Whole system improved: </a:t>
-            </a:r>
-            <a:r>
-              <a:rPr sz="1800" b="0"/>
-              <a:t>real 10-site run 0.999 detection (was 0.889)</a:t>
-            </a:r>
-          </a:p>
-          <a:p>
-            <a:pPr>
-              <a:spcAft>
-                <a:spcPts val="800"/>
-              </a:spcAft>
-            </a:pPr>
-            <a:r>
-              <a:rPr sz="1800" b="1"/>
-              <a:t>Catches new attacks: </a:t>
-            </a:r>
-            <a:r>
-              <a:rPr sz="1800" b="0"/>
-              <a:t>0.94 vs 0.80 detection of never-seen attack types (was 0.74 / 0.53)</a:t>
-            </a:r>
-          </a:p>
-          <a:p>
-            <a:pPr>
-              <a:spcAft>
-                <a:spcPts val="800"/>
-              </a:spcAft>
-            </a:pPr>
-            <a:r>
-              <a:rPr sz="1800" b="1"/>
-              <a:t>Resists sabotage: </a:t>
-            </a:r>
-            <a:r>
-              <a:rPr sz="1800" b="0"/>
-              <a:t>steady with up to 40% malicious sites</a:t>
-            </a:r>
-          </a:p>
-          <a:p>
-            <a:pPr>
-              <a:spcAft>
-                <a:spcPts val="800"/>
-              </a:spcAft>
-            </a:pPr>
-            <a:r>
-              <a:rPr sz="1800" b="1"/>
-              <a:t>Acts automatically: </a:t>
-            </a:r>
-            <a:r>
-              <a:rPr sz="1800" b="0"/>
-              <a:t>detected attacker blocked on the switch, verified</a:t>
-            </a:r>
-          </a:p>
-          <a:p>
-            <a:pPr>
-              <a:spcAft>
-                <a:spcPts val="800"/>
-              </a:spcAft>
-            </a:pPr>
-            <a:r>
-              <a:rPr sz="1800" b="1"/>
-              <a:t>Honest data: </a:t>
-            </a:r>
-            <a:r>
-              <a:rPr sz="1800" b="0"/>
-              <a:t>found and repaired broken MITM rows; fixed a label leak first reported by Galal (2026)</a:t>
-            </a:r>
-          </a:p>
-          <a:p>
-            <a:pPr>
-              <a:spcAft>
-                <a:spcPts val="800"/>
-              </a:spcAft>
-            </a:pPr>
-            <a:r>
-              <a:rPr sz="1800" b="1"/>
-              <a:t>What's novel: </a:t>
-            </a:r>
-            <a:r>
-              <a:rPr sz="1800" b="0"/>
-              <a:t>we found no published system combining all five parts, and the MITM repair</a:t>
-            </a:r>
-          </a:p>
-          <a:p>
-            <a:pPr>
-              <a:spcAft>
-                <a:spcPts val="800"/>
-              </a:spcAft>
-            </a:pPr>
-            <a:r>
-              <a:rPr sz="1800" b="1"/>
-              <a:t>Project complete: </a:t>
-            </a:r>
-            <a:r>
-              <a:rPr sz="1800" b="0"/>
-              <a:t>every planned phase done and verified end to end; paper being written</a:t>
-            </a:r>
+              <a:rPr lang="en-US" dirty="0"/>
+              <a:t>Results: Live Demo (Detect and Block)</a:t>
+            </a:r>
+            <a:endParaRPr lang="en-IN" dirty="0"/>
           </a:p>
         </p:txBody>
       </p:sp>
@@ -12226,7 +11381,7 @@
           <a:p>
             <a:fld id="{840E0BF8-4B7D-46FA-B28A-DDF089F57DAF}" type="slidenum">
               <a:rPr lang="en-IN" smtClean="0"/>
-              <a:t>11</a:t>
+              <a:t>10</a:t>
             </a:fld>
             <a:endParaRPr lang="en-IN"/>
           </a:p>
@@ -12308,10 +11463,841 @@
           </a:p>
         </p:txBody>
       </p:sp>
+      <p:sp>
+        <p:nvSpPr>
+          <p:cNvPr id="8" name="Rounded Rectangle 7"/>
+          <p:cNvSpPr/>
+          <p:nvPr/>
+        </p:nvSpPr>
+        <p:spPr>
+          <a:xfrm>
+            <a:off x="838200" y="1740688"/>
+            <a:ext cx="2463900" cy="1900000"/>
+          </a:xfrm>
+          <a:prstGeom prst="roundRect">
+            <a:avLst>
+              <a:gd name="adj" fmla="val 6000"/>
+            </a:avLst>
+          </a:prstGeom>
+          <a:solidFill>
+            <a:srgbClr val="F1F2F4"/>
+          </a:solidFill>
+          <a:ln>
+            <a:noFill/>
+          </a:ln>
+          <a:effectLst/>
+        </p:spPr>
+        <p:style>
+          <a:lnRef idx="1">
+            <a:schemeClr val="accent1"/>
+          </a:lnRef>
+          <a:fillRef idx="3">
+            <a:schemeClr val="accent1"/>
+          </a:fillRef>
+          <a:effectRef idx="2">
+            <a:schemeClr val="accent1"/>
+          </a:effectRef>
+          <a:fontRef idx="minor">
+            <a:schemeClr val="lt1"/>
+          </a:fontRef>
+        </p:style>
+        <p:txBody>
+          <a:bodyPr rtlCol="0" anchor="t" wrap="square" lIns="150000" rIns="150000" tIns="120000"/>
+          <a:lstStyle/>
+          <a:p>
+            <a:pPr algn="l"/>
+            <a:r>
+              <a:rPr sz="1600" b="1">
+                <a:solidFill>
+                  <a:srgbClr val="5B6770"/>
+                </a:solidFill>
+              </a:rPr>
+              <a:t> </a:t>
+            </a:r>
+          </a:p>
+          <a:p>
+            <a:pPr algn="l">
+              <a:spcBef>
+                <a:spcPts val="500"/>
+              </a:spcBef>
+            </a:pPr>
+            <a:r>
+              <a:rPr sz="1400" b="0">
+                <a:solidFill>
+                  <a:srgbClr val="1B1B1B"/>
+                </a:solidFill>
+              </a:rPr>
+              <a:t>real Backdoor attack capture, 24,914 packets, into the emulated network</a:t>
+            </a:r>
+          </a:p>
+        </p:txBody>
+      </p:sp>
+      <p:sp>
+        <p:nvSpPr>
+          <p:cNvPr id="9" name="TextBox 8"/>
+          <p:cNvSpPr txBox="1"/>
+          <p:nvPr/>
+        </p:nvSpPr>
+        <p:spPr>
+          <a:xfrm>
+            <a:off x="1418200" y="1810688"/>
+            <a:ext cx="1783900" cy="450000"/>
+          </a:xfrm>
+          <a:prstGeom prst="rect">
+            <a:avLst/>
+          </a:prstGeom>
+          <a:noFill/>
+        </p:spPr>
+        <p:txBody>
+          <a:bodyPr wrap="square" anchor="ctr" lIns="0" rIns="0">
+            <a:spAutoFit/>
+          </a:bodyPr>
+          <a:lstStyle/>
+          <a:p>
+            <a:pPr algn="l"/>
+            <a:r>
+              <a:rPr sz="1600" b="1">
+                <a:solidFill>
+                  <a:srgbClr val="5B6770"/>
+                </a:solidFill>
+              </a:rPr>
+              <a:t>Replay</a:t>
+            </a:r>
+          </a:p>
+        </p:txBody>
+      </p:sp>
+      <p:sp>
+        <p:nvSpPr>
+          <p:cNvPr id="10" name="Oval 9"/>
+          <p:cNvSpPr/>
+          <p:nvPr/>
+        </p:nvSpPr>
+        <p:spPr>
+          <a:xfrm>
+            <a:off x="948200" y="1835688"/>
+            <a:ext cx="380000" cy="380000"/>
+          </a:xfrm>
+          <a:prstGeom prst="ellipse">
+            <a:avLst/>
+          </a:prstGeom>
+          <a:solidFill>
+            <a:srgbClr val="5B6770"/>
+          </a:solidFill>
+          <a:ln>
+            <a:noFill/>
+          </a:ln>
+          <a:effectLst/>
+        </p:spPr>
+        <p:style>
+          <a:lnRef idx="1">
+            <a:schemeClr val="accent1"/>
+          </a:lnRef>
+          <a:fillRef idx="3">
+            <a:schemeClr val="accent1"/>
+          </a:fillRef>
+          <a:effectRef idx="2">
+            <a:schemeClr val="accent1"/>
+          </a:effectRef>
+          <a:fontRef idx="minor">
+            <a:schemeClr val="lt1"/>
+          </a:fontRef>
+        </p:style>
+        <p:txBody>
+          <a:bodyPr rtlCol="0" anchor="ctr" lIns="0" rIns="0" tIns="0" bIns="0"/>
+          <a:lstStyle/>
+          <a:p>
+            <a:pPr algn="ctr"/>
+            <a:r>
+              <a:rPr sz="1300" b="1">
+                <a:solidFill>
+                  <a:srgbClr val="FFFFFF"/>
+                </a:solidFill>
+              </a:rPr>
+              <a:t>1</a:t>
+            </a:r>
+          </a:p>
+        </p:txBody>
+      </p:sp>
+      <p:cxnSp>
+        <p:nvCxnSpPr>
+          <p:cNvPr id="11" name="Connector 10"/>
+          <p:cNvCxnSpPr/>
+          <p:nvPr/>
+        </p:nvCxnSpPr>
+        <p:spPr>
+          <a:xfrm>
+            <a:off x="3312100" y="2690688"/>
+            <a:ext cx="200000" cy="0"/>
+          </a:xfrm>
+          <a:prstGeom prst="line">
+            <a:avLst/>
+          </a:prstGeom>
+          <a:ln w="25400">
+            <a:solidFill>
+              <a:srgbClr val="5B6770"/>
+            </a:solidFill>
+            <a:tailEnd type="triangle" w="med" len="med"/>
+          </a:ln>
+        </p:spPr>
+        <p:style>
+          <a:lnRef idx="2">
+            <a:schemeClr val="accent1"/>
+          </a:lnRef>
+          <a:fillRef idx="0">
+            <a:schemeClr val="accent1"/>
+          </a:fillRef>
+          <a:effectRef idx="1">
+            <a:schemeClr val="accent1"/>
+          </a:effectRef>
+          <a:fontRef idx="minor">
+            <a:schemeClr val="tx1"/>
+          </a:fontRef>
+        </p:style>
+      </p:cxnSp>
+      <p:sp>
+        <p:nvSpPr>
+          <p:cNvPr id="12" name="Rounded Rectangle 11"/>
+          <p:cNvSpPr/>
+          <p:nvPr/>
+        </p:nvSpPr>
+        <p:spPr>
+          <a:xfrm>
+            <a:off x="3522100" y="1740688"/>
+            <a:ext cx="2463900" cy="1900000"/>
+          </a:xfrm>
+          <a:prstGeom prst="roundRect">
+            <a:avLst>
+              <a:gd name="adj" fmla="val 6000"/>
+            </a:avLst>
+          </a:prstGeom>
+          <a:solidFill>
+            <a:srgbClr val="E3E7F4"/>
+          </a:solidFill>
+          <a:ln>
+            <a:noFill/>
+          </a:ln>
+          <a:effectLst/>
+        </p:spPr>
+        <p:style>
+          <a:lnRef idx="1">
+            <a:schemeClr val="accent1"/>
+          </a:lnRef>
+          <a:fillRef idx="3">
+            <a:schemeClr val="accent1"/>
+          </a:fillRef>
+          <a:effectRef idx="2">
+            <a:schemeClr val="accent1"/>
+          </a:effectRef>
+          <a:fontRef idx="minor">
+            <a:schemeClr val="lt1"/>
+          </a:fontRef>
+        </p:style>
+        <p:txBody>
+          <a:bodyPr rtlCol="0" anchor="t" wrap="square" lIns="150000" rIns="150000" tIns="120000"/>
+          <a:lstStyle/>
+          <a:p>
+            <a:pPr algn="l"/>
+            <a:r>
+              <a:rPr sz="1600" b="1">
+                <a:solidFill>
+                  <a:srgbClr val="1E2761"/>
+                </a:solidFill>
+              </a:rPr>
+              <a:t> </a:t>
+            </a:r>
+          </a:p>
+          <a:p>
+            <a:pPr algn="l">
+              <a:spcBef>
+                <a:spcPts val="500"/>
+              </a:spcBef>
+            </a:pPr>
+            <a:r>
+              <a:rPr sz="1400" b="0">
+                <a:solidFill>
+                  <a:srgbClr val="1B1B1B"/>
+                </a:solidFill>
+              </a:rPr>
+              <a:t>classified as Backdoor with 99.7% confidence</a:t>
+            </a:r>
+          </a:p>
+        </p:txBody>
+      </p:sp>
+      <p:sp>
+        <p:nvSpPr>
+          <p:cNvPr id="13" name="TextBox 12"/>
+          <p:cNvSpPr txBox="1"/>
+          <p:nvPr/>
+        </p:nvSpPr>
+        <p:spPr>
+          <a:xfrm>
+            <a:off x="4102100" y="1810688"/>
+            <a:ext cx="1783900" cy="450000"/>
+          </a:xfrm>
+          <a:prstGeom prst="rect">
+            <a:avLst/>
+          </a:prstGeom>
+          <a:noFill/>
+        </p:spPr>
+        <p:txBody>
+          <a:bodyPr wrap="square" anchor="ctr" lIns="0" rIns="0">
+            <a:spAutoFit/>
+          </a:bodyPr>
+          <a:lstStyle/>
+          <a:p>
+            <a:pPr algn="l"/>
+            <a:r>
+              <a:rPr sz="1600" b="1">
+                <a:solidFill>
+                  <a:srgbClr val="1E2761"/>
+                </a:solidFill>
+              </a:rPr>
+              <a:t>Detect</a:t>
+            </a:r>
+          </a:p>
+        </p:txBody>
+      </p:sp>
+      <p:sp>
+        <p:nvSpPr>
+          <p:cNvPr id="14" name="Oval 13"/>
+          <p:cNvSpPr/>
+          <p:nvPr/>
+        </p:nvSpPr>
+        <p:spPr>
+          <a:xfrm>
+            <a:off x="3632100" y="1835688"/>
+            <a:ext cx="380000" cy="380000"/>
+          </a:xfrm>
+          <a:prstGeom prst="ellipse">
+            <a:avLst/>
+          </a:prstGeom>
+          <a:solidFill>
+            <a:srgbClr val="1E2761"/>
+          </a:solidFill>
+          <a:ln>
+            <a:noFill/>
+          </a:ln>
+          <a:effectLst/>
+        </p:spPr>
+        <p:style>
+          <a:lnRef idx="1">
+            <a:schemeClr val="accent1"/>
+          </a:lnRef>
+          <a:fillRef idx="3">
+            <a:schemeClr val="accent1"/>
+          </a:fillRef>
+          <a:effectRef idx="2">
+            <a:schemeClr val="accent1"/>
+          </a:effectRef>
+          <a:fontRef idx="minor">
+            <a:schemeClr val="lt1"/>
+          </a:fontRef>
+        </p:style>
+        <p:txBody>
+          <a:bodyPr rtlCol="0" anchor="ctr" lIns="0" rIns="0" tIns="0" bIns="0"/>
+          <a:lstStyle/>
+          <a:p>
+            <a:pPr algn="ctr"/>
+            <a:r>
+              <a:rPr sz="1300" b="1">
+                <a:solidFill>
+                  <a:srgbClr val="FFFFFF"/>
+                </a:solidFill>
+              </a:rPr>
+              <a:t>2</a:t>
+            </a:r>
+          </a:p>
+        </p:txBody>
+      </p:sp>
+      <p:cxnSp>
+        <p:nvCxnSpPr>
+          <p:cNvPr id="15" name="Connector 14"/>
+          <p:cNvCxnSpPr/>
+          <p:nvPr/>
+        </p:nvCxnSpPr>
+        <p:spPr>
+          <a:xfrm>
+            <a:off x="5996000" y="2690688"/>
+            <a:ext cx="200000" cy="0"/>
+          </a:xfrm>
+          <a:prstGeom prst="line">
+            <a:avLst/>
+          </a:prstGeom>
+          <a:ln w="25400">
+            <a:solidFill>
+              <a:srgbClr val="5B6770"/>
+            </a:solidFill>
+            <a:tailEnd type="triangle" w="med" len="med"/>
+          </a:ln>
+        </p:spPr>
+        <p:style>
+          <a:lnRef idx="2">
+            <a:schemeClr val="accent1"/>
+          </a:lnRef>
+          <a:fillRef idx="0">
+            <a:schemeClr val="accent1"/>
+          </a:fillRef>
+          <a:effectRef idx="1">
+            <a:schemeClr val="accent1"/>
+          </a:effectRef>
+          <a:fontRef idx="minor">
+            <a:schemeClr val="tx1"/>
+          </a:fontRef>
+        </p:style>
+      </p:cxnSp>
+      <p:sp>
+        <p:nvSpPr>
+          <p:cNvPr id="16" name="Rounded Rectangle 15"/>
+          <p:cNvSpPr/>
+          <p:nvPr/>
+        </p:nvSpPr>
+        <p:spPr>
+          <a:xfrm>
+            <a:off x="6206000" y="1740688"/>
+            <a:ext cx="2463900" cy="1900000"/>
+          </a:xfrm>
+          <a:prstGeom prst="roundRect">
+            <a:avLst>
+              <a:gd name="adj" fmla="val 6000"/>
+            </a:avLst>
+          </a:prstGeom>
+          <a:solidFill>
+            <a:srgbClr val="FBF0D9"/>
+          </a:solidFill>
+          <a:ln>
+            <a:noFill/>
+          </a:ln>
+          <a:effectLst/>
+        </p:spPr>
+        <p:style>
+          <a:lnRef idx="1">
+            <a:schemeClr val="accent1"/>
+          </a:lnRef>
+          <a:fillRef idx="3">
+            <a:schemeClr val="accent1"/>
+          </a:fillRef>
+          <a:effectRef idx="2">
+            <a:schemeClr val="accent1"/>
+          </a:effectRef>
+          <a:fontRef idx="minor">
+            <a:schemeClr val="lt1"/>
+          </a:fontRef>
+        </p:style>
+        <p:txBody>
+          <a:bodyPr rtlCol="0" anchor="t" wrap="square" lIns="150000" rIns="150000" tIns="120000"/>
+          <a:lstStyle/>
+          <a:p>
+            <a:pPr algn="l"/>
+            <a:r>
+              <a:rPr sz="1600" b="1">
+                <a:solidFill>
+                  <a:srgbClr val="C98A0B"/>
+                </a:solidFill>
+              </a:rPr>
+              <a:t> </a:t>
+            </a:r>
+          </a:p>
+          <a:p>
+            <a:pPr algn="l">
+              <a:spcBef>
+                <a:spcPts val="500"/>
+              </a:spcBef>
+            </a:pPr>
+            <a:r>
+              <a:rPr sz="1400" b="0">
+                <a:solidFill>
+                  <a:srgbClr val="1B1B1B"/>
+                </a:solidFill>
+              </a:rPr>
+              <a:t>confidence ≥ 85% → block</a:t>
+            </a:r>
+          </a:p>
+        </p:txBody>
+      </p:sp>
+      <p:sp>
+        <p:nvSpPr>
+          <p:cNvPr id="17" name="TextBox 16"/>
+          <p:cNvSpPr txBox="1"/>
+          <p:nvPr/>
+        </p:nvSpPr>
+        <p:spPr>
+          <a:xfrm>
+            <a:off x="6786000" y="1810688"/>
+            <a:ext cx="1783900" cy="450000"/>
+          </a:xfrm>
+          <a:prstGeom prst="rect">
+            <a:avLst/>
+          </a:prstGeom>
+          <a:noFill/>
+        </p:spPr>
+        <p:txBody>
+          <a:bodyPr wrap="square" anchor="ctr" lIns="0" rIns="0">
+            <a:spAutoFit/>
+          </a:bodyPr>
+          <a:lstStyle/>
+          <a:p>
+            <a:pPr algn="l"/>
+            <a:r>
+              <a:rPr sz="1600" b="1">
+                <a:solidFill>
+                  <a:srgbClr val="C98A0B"/>
+                </a:solidFill>
+              </a:rPr>
+              <a:t>Decide</a:t>
+            </a:r>
+          </a:p>
+        </p:txBody>
+      </p:sp>
+      <p:sp>
+        <p:nvSpPr>
+          <p:cNvPr id="18" name="Oval 17"/>
+          <p:cNvSpPr/>
+          <p:nvPr/>
+        </p:nvSpPr>
+        <p:spPr>
+          <a:xfrm>
+            <a:off x="6316000" y="1835688"/>
+            <a:ext cx="380000" cy="380000"/>
+          </a:xfrm>
+          <a:prstGeom prst="ellipse">
+            <a:avLst/>
+          </a:prstGeom>
+          <a:solidFill>
+            <a:srgbClr val="C98A0B"/>
+          </a:solidFill>
+          <a:ln>
+            <a:noFill/>
+          </a:ln>
+          <a:effectLst/>
+        </p:spPr>
+        <p:style>
+          <a:lnRef idx="1">
+            <a:schemeClr val="accent1"/>
+          </a:lnRef>
+          <a:fillRef idx="3">
+            <a:schemeClr val="accent1"/>
+          </a:fillRef>
+          <a:effectRef idx="2">
+            <a:schemeClr val="accent1"/>
+          </a:effectRef>
+          <a:fontRef idx="minor">
+            <a:schemeClr val="lt1"/>
+          </a:fontRef>
+        </p:style>
+        <p:txBody>
+          <a:bodyPr rtlCol="0" anchor="ctr" lIns="0" rIns="0" tIns="0" bIns="0"/>
+          <a:lstStyle/>
+          <a:p>
+            <a:pPr algn="ctr"/>
+            <a:r>
+              <a:rPr sz="1300" b="1">
+                <a:solidFill>
+                  <a:srgbClr val="FFFFFF"/>
+                </a:solidFill>
+              </a:rPr>
+              <a:t>3</a:t>
+            </a:r>
+          </a:p>
+        </p:txBody>
+      </p:sp>
+      <p:cxnSp>
+        <p:nvCxnSpPr>
+          <p:cNvPr id="19" name="Connector 18"/>
+          <p:cNvCxnSpPr/>
+          <p:nvPr/>
+        </p:nvCxnSpPr>
+        <p:spPr>
+          <a:xfrm>
+            <a:off x="8679900" y="2690688"/>
+            <a:ext cx="200000" cy="0"/>
+          </a:xfrm>
+          <a:prstGeom prst="line">
+            <a:avLst/>
+          </a:prstGeom>
+          <a:ln w="25400">
+            <a:solidFill>
+              <a:srgbClr val="5B6770"/>
+            </a:solidFill>
+            <a:tailEnd type="triangle" w="med" len="med"/>
+          </a:ln>
+        </p:spPr>
+        <p:style>
+          <a:lnRef idx="2">
+            <a:schemeClr val="accent1"/>
+          </a:lnRef>
+          <a:fillRef idx="0">
+            <a:schemeClr val="accent1"/>
+          </a:fillRef>
+          <a:effectRef idx="1">
+            <a:schemeClr val="accent1"/>
+          </a:effectRef>
+          <a:fontRef idx="minor">
+            <a:schemeClr val="tx1"/>
+          </a:fontRef>
+        </p:style>
+      </p:cxnSp>
+      <p:sp>
+        <p:nvSpPr>
+          <p:cNvPr id="20" name="Rounded Rectangle 19"/>
+          <p:cNvSpPr/>
+          <p:nvPr/>
+        </p:nvSpPr>
+        <p:spPr>
+          <a:xfrm>
+            <a:off x="8889900" y="1740688"/>
+            <a:ext cx="2463900" cy="1900000"/>
+          </a:xfrm>
+          <a:prstGeom prst="roundRect">
+            <a:avLst>
+              <a:gd name="adj" fmla="val 6000"/>
+            </a:avLst>
+          </a:prstGeom>
+          <a:solidFill>
+            <a:srgbClr val="F9E1E3"/>
+          </a:solidFill>
+          <a:ln>
+            <a:noFill/>
+          </a:ln>
+          <a:effectLst/>
+        </p:spPr>
+        <p:style>
+          <a:lnRef idx="1">
+            <a:schemeClr val="accent1"/>
+          </a:lnRef>
+          <a:fillRef idx="3">
+            <a:schemeClr val="accent1"/>
+          </a:fillRef>
+          <a:effectRef idx="2">
+            <a:schemeClr val="accent1"/>
+          </a:effectRef>
+          <a:fontRef idx="minor">
+            <a:schemeClr val="lt1"/>
+          </a:fontRef>
+        </p:style>
+        <p:txBody>
+          <a:bodyPr rtlCol="0" anchor="t" wrap="square" lIns="150000" rIns="150000" tIns="120000"/>
+          <a:lstStyle/>
+          <a:p>
+            <a:pPr algn="l"/>
+            <a:r>
+              <a:rPr sz="1600" b="1">
+                <a:solidFill>
+                  <a:srgbClr val="D64550"/>
+                </a:solidFill>
+              </a:rPr>
+              <a:t> </a:t>
+            </a:r>
+          </a:p>
+          <a:p>
+            <a:pPr algn="l">
+              <a:spcBef>
+                <a:spcPts val="500"/>
+              </a:spcBef>
+            </a:pPr>
+            <a:r>
+              <a:rPr sz="1400" b="0">
+                <a:solidFill>
+                  <a:srgbClr val="1B1B1B"/>
+                </a:solidFill>
+              </a:rPr>
+              <a:t>drop rule installed on the switch and read back to confirm</a:t>
+            </a:r>
+          </a:p>
+        </p:txBody>
+      </p:sp>
+      <p:sp>
+        <p:nvSpPr>
+          <p:cNvPr id="21" name="TextBox 20"/>
+          <p:cNvSpPr txBox="1"/>
+          <p:nvPr/>
+        </p:nvSpPr>
+        <p:spPr>
+          <a:xfrm>
+            <a:off x="9469900" y="1810688"/>
+            <a:ext cx="1783900" cy="450000"/>
+          </a:xfrm>
+          <a:prstGeom prst="rect">
+            <a:avLst/>
+          </a:prstGeom>
+          <a:noFill/>
+        </p:spPr>
+        <p:txBody>
+          <a:bodyPr wrap="square" anchor="ctr" lIns="0" rIns="0">
+            <a:spAutoFit/>
+          </a:bodyPr>
+          <a:lstStyle/>
+          <a:p>
+            <a:pPr algn="l"/>
+            <a:r>
+              <a:rPr sz="1600" b="1">
+                <a:solidFill>
+                  <a:srgbClr val="D64550"/>
+                </a:solidFill>
+              </a:rPr>
+              <a:t>Block</a:t>
+            </a:r>
+          </a:p>
+        </p:txBody>
+      </p:sp>
+      <p:sp>
+        <p:nvSpPr>
+          <p:cNvPr id="22" name="Oval 21"/>
+          <p:cNvSpPr/>
+          <p:nvPr/>
+        </p:nvSpPr>
+        <p:spPr>
+          <a:xfrm>
+            <a:off x="8999900" y="1835688"/>
+            <a:ext cx="380000" cy="380000"/>
+          </a:xfrm>
+          <a:prstGeom prst="ellipse">
+            <a:avLst/>
+          </a:prstGeom>
+          <a:solidFill>
+            <a:srgbClr val="D64550"/>
+          </a:solidFill>
+          <a:ln>
+            <a:noFill/>
+          </a:ln>
+          <a:effectLst/>
+        </p:spPr>
+        <p:style>
+          <a:lnRef idx="1">
+            <a:schemeClr val="accent1"/>
+          </a:lnRef>
+          <a:fillRef idx="3">
+            <a:schemeClr val="accent1"/>
+          </a:fillRef>
+          <a:effectRef idx="2">
+            <a:schemeClr val="accent1"/>
+          </a:effectRef>
+          <a:fontRef idx="minor">
+            <a:schemeClr val="lt1"/>
+          </a:fontRef>
+        </p:style>
+        <p:txBody>
+          <a:bodyPr rtlCol="0" anchor="ctr" lIns="0" rIns="0" tIns="0" bIns="0"/>
+          <a:lstStyle/>
+          <a:p>
+            <a:pPr algn="ctr"/>
+            <a:r>
+              <a:rPr sz="1300" b="1">
+                <a:solidFill>
+                  <a:srgbClr val="FFFFFF"/>
+                </a:solidFill>
+              </a:rPr>
+              <a:t>4</a:t>
+            </a:r>
+          </a:p>
+        </p:txBody>
+      </p:sp>
+      <p:sp>
+        <p:nvSpPr>
+          <p:cNvPr id="23" name="Rounded Rectangle 22"/>
+          <p:cNvSpPr/>
+          <p:nvPr/>
+        </p:nvSpPr>
+        <p:spPr>
+          <a:xfrm>
+            <a:off x="838200" y="3890688"/>
+            <a:ext cx="10515600" cy="900000"/>
+          </a:xfrm>
+          <a:prstGeom prst="roundRect">
+            <a:avLst>
+              <a:gd name="adj" fmla="val 6000"/>
+            </a:avLst>
+          </a:prstGeom>
+          <a:solidFill>
+            <a:srgbClr val="F1F2F4"/>
+          </a:solidFill>
+          <a:ln>
+            <a:noFill/>
+          </a:ln>
+          <a:effectLst/>
+        </p:spPr>
+        <p:style>
+          <a:lnRef idx="1">
+            <a:schemeClr val="accent1"/>
+          </a:lnRef>
+          <a:fillRef idx="3">
+            <a:schemeClr val="accent1"/>
+          </a:fillRef>
+          <a:effectRef idx="2">
+            <a:schemeClr val="accent1"/>
+          </a:effectRef>
+          <a:fontRef idx="minor">
+            <a:schemeClr val="lt1"/>
+          </a:fontRef>
+        </p:style>
+        <p:txBody>
+          <a:bodyPr rtlCol="0" anchor="t" wrap="square" lIns="150000" rIns="150000" tIns="120000"/>
+          <a:lstStyle/>
+          <a:p>
+            <a:pPr algn="l"/>
+            <a:r>
+              <a:rPr sz="1500" b="1">
+                <a:solidFill>
+                  <a:srgbClr val="D64550"/>
+                </a:solidFill>
+              </a:rPr>
+              <a:t>Rule on the switch</a:t>
+            </a:r>
+          </a:p>
+          <a:p>
+            <a:pPr algn="l">
+              <a:spcBef>
+                <a:spcPts val="500"/>
+              </a:spcBef>
+            </a:pPr>
+            <a:r>
+              <a:rPr sz="1600" b="0">
+                <a:solidFill>
+                  <a:srgbClr val="1B1B1B"/>
+                </a:solidFill>
+              </a:rPr>
+              <a:t>priority=100, ip, nw_src=10.0.0.1  actions=drop</a:t>
+            </a:r>
+          </a:p>
+        </p:txBody>
+      </p:sp>
+      <p:sp>
+        <p:nvSpPr>
+          <p:cNvPr id="24" name="TextBox 23"/>
+          <p:cNvSpPr txBox="1"/>
+          <p:nvPr/>
+        </p:nvSpPr>
+        <p:spPr>
+          <a:xfrm>
+            <a:off x="838200" y="4940688"/>
+            <a:ext cx="10515600" cy="900000"/>
+          </a:xfrm>
+          <a:prstGeom prst="rect">
+            <a:avLst/>
+          </a:prstGeom>
+          <a:noFill/>
+        </p:spPr>
+        <p:txBody>
+          <a:bodyPr wrap="square" anchor="t" lIns="0" rIns="0">
+            <a:spAutoFit/>
+          </a:bodyPr>
+          <a:lstStyle/>
+          <a:p>
+            <a:pPr algn="l"/>
+            <a:r>
+              <a:rPr sz="1400" b="0">
+                <a:solidFill>
+                  <a:srgbClr val="5B6770"/>
+                </a:solidFill>
+              </a:rPr>
+              <a:t>Real 10-site federated run: 0.999 attack detection (was 0.889), 3.5% false alarms. 24,669 of 24,914 packets flagged.  Limitation: the decision is made after the capture is analysed, not packet by packet.</a:t>
+            </a:r>
+          </a:p>
+        </p:txBody>
+      </p:sp>
     </p:spTree>
     <p:extLst>
       <p:ext uri="{BB962C8B-B14F-4D97-AF65-F5344CB8AC3E}">
-        <p14:creationId xmlns:p14="http://schemas.microsoft.com/office/powerpoint/2010/main" val="586583528"/>
+        <p14:creationId xmlns:p14="http://schemas.microsoft.com/office/powerpoint/2010/main" val="339988347"/>
       </p:ext>
     </p:extLst>
   </p:cSld>
@@ -12322,7 +12308,7 @@
 </file>
 
 <file path=ppt/slides/slide21.xml><?xml version="1.0" encoding="utf-8"?>
-<p:sld xmlns:a="http://schemas.openxmlformats.org/drawingml/2006/main" xmlns:r="http://schemas.openxmlformats.org/officeDocument/2006/relationships" xmlns:p="http://schemas.openxmlformats.org/presentationml/2006/main">
+<p:sld xmlns:a="http://schemas.openxmlformats.org/drawingml/2006/main" xmlns:p="http://schemas.openxmlformats.org/presentationml/2006/main" xmlns:r="http://schemas.openxmlformats.org/officeDocument/2006/relationships">
   <p:cSld>
     <p:spTree>
       <p:nvGrpSpPr>
@@ -12330,14 +12316,7 @@
         <p:cNvGrpSpPr/>
         <p:nvPr/>
       </p:nvGrpSpPr>
-      <p:grpSpPr>
-        <a:xfrm>
-          <a:off x="0" y="0"/>
-          <a:ext cx="0" cy="0"/>
-          <a:chOff x="0" y="0"/>
-          <a:chExt cx="0" cy="0"/>
-        </a:xfrm>
-      </p:grpSpPr>
+      <p:grpSpPr/>
       <p:sp>
         <p:nvSpPr>
           <p:cNvPr id="2" name="Title 1"/>
@@ -12354,92 +12333,10 @@
           <a:lstStyle/>
           <a:p>
             <a:r>
-              <a:rPr lang="en-IN" dirty="0"/>
-              <a:t>Future Enhancements</a:t>
-            </a:r>
-          </a:p>
-        </p:txBody>
-      </p:sp>
-      <p:sp>
-        <p:nvSpPr>
-          <p:cNvPr id="3" name="Content Placeholder 2"/>
-          <p:cNvSpPr>
-            <a:spLocks noGrp="1"/>
-          </p:cNvSpPr>
-          <p:nvPr>
-            <p:ph idx="1"/>
-          </p:nvPr>
-        </p:nvSpPr>
-        <p:spPr/>
-        <p:txBody>
-          <a:bodyPr wrap="square"/>
-          <a:lstStyle/>
-          <a:p>
-            <a:pPr>
-              <a:spcAft>
-                <a:spcPts val="1000"/>
-              </a:spcAft>
-            </a:pPr>
-            <a:r>
-              <a:rPr sz="1900" b="0"/>
-              <a:t>Apply weight pruning to shrink the model and its updates (Objective 3)</a:t>
-            </a:r>
-            <a:endParaRPr lang="en-IN"/>
-          </a:p>
-          <a:p>
-            <a:pPr>
-              <a:spcAft>
-                <a:spcPts val="1000"/>
-              </a:spcAft>
-            </a:pPr>
-            <a:r>
-              <a:rPr sz="1900" b="0"/>
-              <a:t>Block attacks while they are still happening (decide after the first few packets)</a:t>
-            </a:r>
-          </a:p>
-          <a:p>
-            <a:pPr>
-              <a:spcAft>
-                <a:spcPts val="1000"/>
-              </a:spcAft>
-            </a:pPr>
-            <a:r>
-              <a:rPr sz="1900" b="0"/>
-              <a:t>Test smarter attackers, and more than 50% bad sites</a:t>
-            </a:r>
-          </a:p>
-          <a:p>
-            <a:pPr>
-              <a:spcAft>
-                <a:spcPts val="1000"/>
-              </a:spcAft>
-            </a:pPr>
-            <a:r>
-              <a:rPr sz="1900" b="0"/>
-              <a:t>Repeat every federated experiment with several seeds</a:t>
-            </a:r>
-          </a:p>
-          <a:p>
-            <a:pPr>
-              <a:spcAft>
-                <a:spcPts val="1000"/>
-              </a:spcAft>
-            </a:pPr>
-            <a:r>
-              <a:rPr sz="1900" b="0"/>
-              <a:t>Test on a second dataset that includes normal web traffic</a:t>
-            </a:r>
-          </a:p>
-          <a:p>
-            <a:pPr>
-              <a:spcAft>
-                <a:spcPts val="1000"/>
-              </a:spcAft>
-            </a:pPr>
-            <a:r>
-              <a:rPr sz="1900" b="0"/>
-              <a:t>Deploy on real edge devices and a hardware switch</a:t>
-            </a:r>
+              <a:rPr lang="en-US" dirty="0"/>
+              <a:t>Results: One Whole Run, Timed</a:t>
+            </a:r>
+            <a:endParaRPr lang="en-IN" dirty="0"/>
           </a:p>
         </p:txBody>
       </p:sp>
@@ -12482,7 +12379,7 @@
           <a:p>
             <a:fld id="{840E0BF8-4B7D-46FA-B28A-DDF089F57DAF}" type="slidenum">
               <a:rPr lang="en-IN" smtClean="0"/>
-              <a:t>12</a:t>
+              <a:t>10</a:t>
             </a:fld>
             <a:endParaRPr lang="en-IN"/>
           </a:p>
@@ -12490,26 +12387,19 @@
       </p:sp>
       <p:pic>
         <p:nvPicPr>
-          <p:cNvPr id="6" name="Picture 1"/>
+          <p:cNvPr id="6" name="Picture 5" descr="image.jpeg"/>
           <p:cNvPicPr>
             <a:picLocks noChangeAspect="1"/>
           </p:cNvPicPr>
           <p:nvPr/>
         </p:nvPicPr>
         <p:blipFill>
-          <a:blip r:embed="rId2">
-            <a:extLst>
-              <a:ext uri="{28A0092B-C50C-407E-A947-70E740481C1C}">
-                <a14:useLocalDpi xmlns:a14="http://schemas.microsoft.com/office/drawing/2010/main" val="0"/>
-              </a:ext>
-            </a:extLst>
-          </a:blip>
-          <a:srcRect/>
+          <a:blip r:embed="rId2"/>
           <a:stretch>
             <a:fillRect/>
           </a:stretch>
         </p:blipFill>
-        <p:spPr bwMode="auto">
+        <p:spPr>
           <a:xfrm>
             <a:off x="11028362" y="19050"/>
             <a:ext cx="1163638" cy="1144588"/>
@@ -12517,59 +12407,124 @@
           <a:prstGeom prst="rect">
             <a:avLst/>
           </a:prstGeom>
-          <a:noFill/>
+        </p:spPr>
+      </p:pic>
+      <p:sp>
+        <p:nvSpPr>
+          <p:cNvPr id="7" name="Date Placeholder 6"/>
+          <p:cNvSpPr>
+            <a:spLocks noGrp="1"/>
+          </p:cNvSpPr>
+          <p:nvPr>
+            <p:ph type="dt" sz="half" idx="10"/>
+          </p:nvPr>
+        </p:nvSpPr>
+        <p:spPr/>
+        <p:txBody>
+          <a:bodyPr/>
+          <a:lstStyle/>
+          <a:p>
+            <a:r>
+              <a:rPr lang="en-IN"/>
+              <a:t>16-10-2026</a:t>
+            </a:r>
+          </a:p>
+        </p:txBody>
+      </p:sp>
+      <p:pic>
+        <p:nvPicPr>
+          <p:cNvPr id="8" name="Picture 7" descr="image.png"/>
+          <p:cNvPicPr>
+            <a:picLocks noChangeAspect="1"/>
+          </p:cNvPicPr>
+          <p:nvPr/>
+        </p:nvPicPr>
+        <p:blipFill>
+          <a:blip r:embed="rId3"/>
+          <a:stretch>
+            <a:fillRect/>
+          </a:stretch>
+        </p:blipFill>
+        <p:spPr>
+          <a:xfrm>
+            <a:off x="2036068" y="1540688"/>
+            <a:ext cx="8119863" cy="3000000"/>
+          </a:xfrm>
+          <a:prstGeom prst="rect">
+            <a:avLst/>
+          </a:prstGeom>
+        </p:spPr>
+      </p:pic>
+      <p:sp>
+        <p:nvSpPr>
+          <p:cNvPr id="9" name="Rounded Rectangle 8"/>
+          <p:cNvSpPr/>
+          <p:nvPr/>
+        </p:nvSpPr>
+        <p:spPr>
+          <a:xfrm>
+            <a:off x="838200" y="4640688"/>
+            <a:ext cx="10515600" cy="1250000"/>
+          </a:xfrm>
+          <a:prstGeom prst="roundRect">
+            <a:avLst>
+              <a:gd name="adj" fmla="val 6000"/>
+            </a:avLst>
+          </a:prstGeom>
+          <a:solidFill>
+            <a:srgbClr val="F1F2F4"/>
+          </a:solidFill>
           <a:ln>
             <a:noFill/>
           </a:ln>
-          <a:extLst>
-            <a:ext uri="{909E8E84-426E-40DD-AFC4-6F175D3DCCD1}">
-              <a14:hiddenFill xmlns:a14="http://schemas.microsoft.com/office/drawing/2010/main">
-                <a:solidFill>
-                  <a:srgbClr val="FFFFFF"/>
-                </a:solidFill>
-              </a14:hiddenFill>
-            </a:ext>
-            <a:ext uri="{91240B29-F687-4F45-9708-019B960494DF}">
-              <a14:hiddenLine xmlns:a14="http://schemas.microsoft.com/office/drawing/2010/main" w="9525">
-                <a:solidFill>
-                  <a:srgbClr val="000000"/>
-                </a:solidFill>
-                <a:miter lim="800000"/>
-                <a:headEnd/>
-                <a:tailEnd/>
-              </a14:hiddenLine>
-            </a:ext>
-          </a:extLst>
-        </p:spPr>
-      </p:pic>
-      <p:sp>
-        <p:nvSpPr>
-          <p:cNvPr id="7" name="Date Placeholder 6"/>
-          <p:cNvSpPr>
-            <a:spLocks noGrp="1"/>
-          </p:cNvSpPr>
-          <p:nvPr>
-            <p:ph type="dt" sz="half" idx="10"/>
-          </p:nvPr>
-        </p:nvSpPr>
-        <p:spPr/>
-        <p:txBody>
-          <a:bodyPr/>
-          <a:lstStyle/>
-          <a:p>
-            <a:r>
-              <a:rPr lang="en-IN"/>
-              <a:t>16-10-2026</a:t>
+          <a:effectLst/>
+        </p:spPr>
+        <p:style>
+          <a:lnRef idx="1">
+            <a:schemeClr val="accent1"/>
+          </a:lnRef>
+          <a:fillRef idx="3">
+            <a:schemeClr val="accent1"/>
+          </a:fillRef>
+          <a:effectRef idx="2">
+            <a:schemeClr val="accent1"/>
+          </a:effectRef>
+          <a:fontRef idx="minor">
+            <a:schemeClr val="lt1"/>
+          </a:fontRef>
+        </p:style>
+        <p:txBody>
+          <a:bodyPr rtlCol="0" anchor="t" wrap="square" lIns="150000" rIns="150000" tIns="120000"/>
+          <a:lstStyle/>
+          <a:p>
+            <a:pPr algn="l"/>
+            <a:r>
+              <a:rPr sz="1500" b="1">
+                <a:solidFill>
+                  <a:srgbClr val="1E2761"/>
+                </a:solidFill>
+              </a:rPr>
+              <a:t>What it shows</a:t>
+            </a:r>
+          </a:p>
+          <a:p>
+            <a:pPr algn="l">
+              <a:spcBef>
+                <a:spcPts val="500"/>
+              </a:spcBef>
+            </a:pPr>
+            <a:r>
+              <a:rPr sz="1400" b="0">
+                <a:solidFill>
+                  <a:srgbClr val="1B1B1B"/>
+                </a:solidFill>
+              </a:rPr>
+              <a:t>A complete run, from raw data to a block rule on the switch, took about 219 seconds. Training the shared model is almost all of it; once a model exists, spotting and blocking an attack takes seconds.</a:t>
             </a:r>
           </a:p>
         </p:txBody>
       </p:sp>
     </p:spTree>
-    <p:extLst>
-      <p:ext uri="{BB962C8B-B14F-4D97-AF65-F5344CB8AC3E}">
-        <p14:creationId xmlns:p14="http://schemas.microsoft.com/office/powerpoint/2010/main" val="3954442225"/>
-      </p:ext>
-    </p:extLst>
   </p:cSld>
   <p:clrMapOvr>
     <a:masterClrMapping/>
@@ -12578,7 +12533,7 @@
 </file>
 
 <file path=ppt/slides/slide22.xml><?xml version="1.0" encoding="utf-8"?>
-<p:sld xmlns:a="http://schemas.openxmlformats.org/drawingml/2006/main" xmlns:r="http://schemas.openxmlformats.org/officeDocument/2006/relationships" xmlns:p="http://schemas.openxmlformats.org/presentationml/2006/main">
+<p:sld xmlns:a="http://schemas.openxmlformats.org/drawingml/2006/main" xmlns:p="http://schemas.openxmlformats.org/presentationml/2006/main" xmlns:r="http://schemas.openxmlformats.org/officeDocument/2006/relationships">
   <p:cSld>
     <p:spTree>
       <p:nvGrpSpPr>
@@ -12586,14 +12541,7 @@
         <p:cNvGrpSpPr/>
         <p:nvPr/>
       </p:nvGrpSpPr>
-      <p:grpSpPr>
-        <a:xfrm>
-          <a:off x="0" y="0"/>
-          <a:ext cx="0" cy="0"/>
-          <a:chOff x="0" y="0"/>
-          <a:chExt cx="0" cy="0"/>
-        </a:xfrm>
-      </p:grpSpPr>
+      <p:grpSpPr/>
       <p:sp>
         <p:nvSpPr>
           <p:cNvPr id="2" name="Title 1"/>
@@ -12610,71 +12558,10 @@
           <a:lstStyle/>
           <a:p>
             <a:r>
-              <a:rPr lang="en-IN" dirty="0"/>
-              <a:t>Papers Published</a:t>
-            </a:r>
-          </a:p>
-        </p:txBody>
-      </p:sp>
-      <p:sp>
-        <p:nvSpPr>
-          <p:cNvPr id="3" name="Content Placeholder 2"/>
-          <p:cNvSpPr>
-            <a:spLocks noGrp="1"/>
-          </p:cNvSpPr>
-          <p:nvPr>
-            <p:ph idx="1"/>
-          </p:nvPr>
-        </p:nvSpPr>
-        <p:spPr/>
-        <p:txBody>
-          <a:bodyPr wrap="square"/>
-          <a:lstStyle/>
-          <a:p>
-            <a:pPr>
-              <a:spcAft>
-                <a:spcPts val="1200"/>
-              </a:spcAft>
-            </a:pPr>
-            <a:r>
-              <a:rPr sz="2000" b="1"/>
-              <a:t>Status: </a:t>
-            </a:r>
-            <a:r>
-              <a:rPr sz="2000" b="0"/>
-              <a:t>paper in preparation (draft in progress)</a:t>
-            </a:r>
-            <a:endParaRPr lang="en-IN"/>
-          </a:p>
-          <a:p>
-            <a:pPr>
-              <a:spcAft>
-                <a:spcPts val="1200"/>
-              </a:spcAft>
-            </a:pPr>
-            <a:r>
-              <a:rPr sz="2000" b="1"/>
-              <a:t>Working title: </a:t>
-            </a:r>
-            <a:r>
-              <a:rPr sz="2000" b="0"/>
-              <a:t>FL-IDS: Federated Learning-Based Intrusion Detection System for IoT/IIoT</a:t>
-            </a:r>
-          </a:p>
-          <a:p>
-            <a:pPr>
-              <a:spcAft>
-                <a:spcPts val="1200"/>
-              </a:spcAft>
-            </a:pPr>
-            <a:r>
-              <a:rPr sz="2000" b="1"/>
-              <a:t>Venue: </a:t>
-            </a:r>
-            <a:r>
-              <a:rPr sz="2000" b="0"/>
-              <a:t>not yet submitted</a:t>
-            </a:r>
+              <a:rPr lang="en-US" dirty="0"/>
+              <a:t>Results: Pruning and Smarter Attackers</a:t>
+            </a:r>
+            <a:endParaRPr lang="en-IN" dirty="0"/>
           </a:p>
         </p:txBody>
       </p:sp>
@@ -12717,7 +12604,7 @@
           <a:p>
             <a:fld id="{840E0BF8-4B7D-46FA-B28A-DDF089F57DAF}" type="slidenum">
               <a:rPr lang="en-IN" smtClean="0"/>
-              <a:t>13</a:t>
+              <a:t>10</a:t>
             </a:fld>
             <a:endParaRPr lang="en-IN"/>
           </a:p>
@@ -12725,26 +12612,19 @@
       </p:sp>
       <p:pic>
         <p:nvPicPr>
-          <p:cNvPr id="6" name="Picture 1"/>
+          <p:cNvPr id="6" name="Picture 5" descr="image.jpeg"/>
           <p:cNvPicPr>
             <a:picLocks noChangeAspect="1"/>
           </p:cNvPicPr>
           <p:nvPr/>
         </p:nvPicPr>
         <p:blipFill>
-          <a:blip r:embed="rId2">
-            <a:extLst>
-              <a:ext uri="{28A0092B-C50C-407E-A947-70E740481C1C}">
-                <a14:useLocalDpi xmlns:a14="http://schemas.microsoft.com/office/drawing/2010/main" val="0"/>
-              </a:ext>
-            </a:extLst>
-          </a:blip>
-          <a:srcRect/>
+          <a:blip r:embed="rId2"/>
           <a:stretch>
             <a:fillRect/>
           </a:stretch>
         </p:blipFill>
-        <p:spPr bwMode="auto">
+        <p:spPr>
           <a:xfrm>
             <a:off x="11028362" y="19050"/>
             <a:ext cx="1163638" cy="1144588"/>
@@ -12752,59 +12632,124 @@
           <a:prstGeom prst="rect">
             <a:avLst/>
           </a:prstGeom>
-          <a:noFill/>
+        </p:spPr>
+      </p:pic>
+      <p:sp>
+        <p:nvSpPr>
+          <p:cNvPr id="7" name="Date Placeholder 6"/>
+          <p:cNvSpPr>
+            <a:spLocks noGrp="1"/>
+          </p:cNvSpPr>
+          <p:nvPr>
+            <p:ph type="dt" sz="half" idx="10"/>
+          </p:nvPr>
+        </p:nvSpPr>
+        <p:spPr/>
+        <p:txBody>
+          <a:bodyPr/>
+          <a:lstStyle/>
+          <a:p>
+            <a:r>
+              <a:rPr lang="en-IN"/>
+              <a:t>16-10-2026</a:t>
+            </a:r>
+          </a:p>
+        </p:txBody>
+      </p:sp>
+      <p:pic>
+        <p:nvPicPr>
+          <p:cNvPr id="8" name="Picture 7" descr="image.png"/>
+          <p:cNvPicPr>
+            <a:picLocks noChangeAspect="1"/>
+          </p:cNvPicPr>
+          <p:nvPr/>
+        </p:nvPicPr>
+        <p:blipFill>
+          <a:blip r:embed="rId3"/>
+          <a:stretch>
+            <a:fillRect/>
+          </a:stretch>
+        </p:blipFill>
+        <p:spPr>
+          <a:xfrm>
+            <a:off x="2036068" y="1540688"/>
+            <a:ext cx="8119863" cy="3000000"/>
+          </a:xfrm>
+          <a:prstGeom prst="rect">
+            <a:avLst/>
+          </a:prstGeom>
+        </p:spPr>
+      </p:pic>
+      <p:sp>
+        <p:nvSpPr>
+          <p:cNvPr id="9" name="Rounded Rectangle 8"/>
+          <p:cNvSpPr/>
+          <p:nvPr/>
+        </p:nvSpPr>
+        <p:spPr>
+          <a:xfrm>
+            <a:off x="838200" y="4640688"/>
+            <a:ext cx="10515600" cy="1250000"/>
+          </a:xfrm>
+          <a:prstGeom prst="roundRect">
+            <a:avLst>
+              <a:gd name="adj" fmla="val 6000"/>
+            </a:avLst>
+          </a:prstGeom>
+          <a:solidFill>
+            <a:srgbClr val="F1F2F4"/>
+          </a:solidFill>
           <a:ln>
             <a:noFill/>
           </a:ln>
-          <a:extLst>
-            <a:ext uri="{909E8E84-426E-40DD-AFC4-6F175D3DCCD1}">
-              <a14:hiddenFill xmlns:a14="http://schemas.microsoft.com/office/drawing/2010/main">
-                <a:solidFill>
-                  <a:srgbClr val="FFFFFF"/>
-                </a:solidFill>
-              </a14:hiddenFill>
-            </a:ext>
-            <a:ext uri="{91240B29-F687-4F45-9708-019B960494DF}">
-              <a14:hiddenLine xmlns:a14="http://schemas.microsoft.com/office/drawing/2010/main" w="9525">
-                <a:solidFill>
-                  <a:srgbClr val="000000"/>
-                </a:solidFill>
-                <a:miter lim="800000"/>
-                <a:headEnd/>
-                <a:tailEnd/>
-              </a14:hiddenLine>
-            </a:ext>
-          </a:extLst>
-        </p:spPr>
-      </p:pic>
-      <p:sp>
-        <p:nvSpPr>
-          <p:cNvPr id="7" name="Date Placeholder 6"/>
-          <p:cNvSpPr>
-            <a:spLocks noGrp="1"/>
-          </p:cNvSpPr>
-          <p:nvPr>
-            <p:ph type="dt" sz="half" idx="10"/>
-          </p:nvPr>
-        </p:nvSpPr>
-        <p:spPr/>
-        <p:txBody>
-          <a:bodyPr/>
-          <a:lstStyle/>
-          <a:p>
-            <a:r>
-              <a:rPr lang="en-IN"/>
-              <a:t>16-10-2026</a:t>
+          <a:effectLst/>
+        </p:spPr>
+        <p:style>
+          <a:lnRef idx="1">
+            <a:schemeClr val="accent1"/>
+          </a:lnRef>
+          <a:fillRef idx="3">
+            <a:schemeClr val="accent1"/>
+          </a:fillRef>
+          <a:effectRef idx="2">
+            <a:schemeClr val="accent1"/>
+          </a:effectRef>
+          <a:fontRef idx="minor">
+            <a:schemeClr val="lt1"/>
+          </a:fontRef>
+        </p:style>
+        <p:txBody>
+          <a:bodyPr rtlCol="0" anchor="t" wrap="square" lIns="150000" rIns="150000" tIns="120000"/>
+          <a:lstStyle/>
+          <a:p>
+            <a:pPr algn="l"/>
+            <a:r>
+              <a:rPr sz="1500" b="1">
+                <a:solidFill>
+                  <a:srgbClr val="1E2761"/>
+                </a:solidFill>
+              </a:rPr>
+              <a:t>What it shows</a:t>
+            </a:r>
+          </a:p>
+          <a:p>
+            <a:pPr algn="l">
+              <a:spcBef>
+                <a:spcPts val="500"/>
+              </a:spcBef>
+            </a:pPr>
+            <a:r>
+              <a:rPr sz="1400" b="0">
+                <a:solidFill>
+                  <a:srgbClr val="1B1B1B"/>
+                </a:solidFill>
+              </a:rPr>
+              <a:t>Removing 70% of the detector's weights costs little if done while training (backstop recall 0.74 to 0.69), but ruins it if done afterwards. A smarter attacker slips past the filter most of the time, though known attacks are still caught. Across 3 seeds, new-attack detection stays 0.94–0.95.</a:t>
             </a:r>
           </a:p>
         </p:txBody>
       </p:sp>
     </p:spTree>
-    <p:extLst>
-      <p:ext uri="{BB962C8B-B14F-4D97-AF65-F5344CB8AC3E}">
-        <p14:creationId xmlns:p14="http://schemas.microsoft.com/office/powerpoint/2010/main" val="3373861349"/>
-      </p:ext>
-    </p:extLst>
   </p:cSld>
   <p:clrMapOvr>
     <a:masterClrMapping/>
@@ -12846,7 +12791,7 @@
           <a:p>
             <a:r>
               <a:rPr lang="en-IN" dirty="0"/>
-              <a:t>References </a:t>
+              <a:t>Conclusion</a:t>
             </a:r>
           </a:p>
         </p:txBody>
@@ -12868,101 +12813,122 @@
           <a:p>
             <a:pPr>
               <a:spcAft>
-                <a:spcPts val="300"/>
+                <a:spcPts val="800"/>
               </a:spcAft>
             </a:pPr>
             <a:r>
-              <a:rPr sz="1300" b="0"/>
-              <a:t>M. A. Ferrag et al., “Edge-IIoTset: A new comprehensive realistic cyber security dataset of IoT and IIoT applications for centralized and federated learning,” IEEE Access, vol. 10, pp. 40281–40306, 2022.</a:t>
+              <a:rPr sz="1800" b="1"/>
+              <a:t>Accuracy target met: </a:t>
+            </a:r>
+            <a:r>
+              <a:rPr sz="1800" b="0"/>
+              <a:t>99.7% accuracy and 0.983 macro F1 on 397k unseen packets (was 96.4% / 0.889)</a:t>
             </a:r>
             <a:endParaRPr lang="en-IN"/>
           </a:p>
           <a:p>
             <a:pPr>
               <a:spcAft>
-                <a:spcPts val="300"/>
+                <a:spcPts val="800"/>
               </a:spcAft>
             </a:pPr>
             <a:r>
-              <a:rPr sz="1300" b="0"/>
-              <a:t>V. Mothukuri et al., “Federated-learning-based anomaly detection for IoT security attacks,” IEEE IoT Journal, vol. 9, no. 4, 2022.</a:t>
+              <a:rPr sz="1800" b="1"/>
+              <a:t>Whole system improved: </a:t>
+            </a:r>
+            <a:r>
+              <a:rPr sz="1800" b="0"/>
+              <a:t>real 10-site run 0.999 detection (was 0.889)</a:t>
             </a:r>
           </a:p>
           <a:p>
             <a:pPr>
               <a:spcAft>
-                <a:spcPts val="300"/>
+                <a:spcPts val="800"/>
               </a:spcAft>
             </a:pPr>
             <a:r>
-              <a:rPr sz="1300" b="0"/>
-              <a:t>B. Li et al., “DeepFed: Federated deep learning for intrusion detection in industrial cyber–physical systems,” IEEE TII, vol. 17, no. 8, 2021.</a:t>
+              <a:rPr sz="1800" b="1"/>
+              <a:t>Catches new attacks: </a:t>
+            </a:r>
+            <a:r>
+              <a:rPr sz="1800" b="0"/>
+              <a:t>0.94 vs 0.80 detection of never-seen attack types (was 0.74 / 0.53)</a:t>
             </a:r>
           </a:p>
           <a:p>
             <a:pPr>
               <a:spcAft>
-                <a:spcPts val="300"/>
+                <a:spcPts val="800"/>
               </a:spcAft>
             </a:pPr>
             <a:r>
-              <a:rPr sz="1300" b="0"/>
-              <a:t>X. Cao, M. Fang, J. Liu, N. Z. Gong, “FLTrust: Byzantine-robust federated learning via trust bootstrapping,” NDSS, 2021.</a:t>
+              <a:rPr sz="1800" b="1"/>
+              <a:t>Resists sabotage: </a:t>
+            </a:r>
+            <a:r>
+              <a:rPr sz="1800" b="0"/>
+              <a:t>steady with up to 40% malicious sites</a:t>
             </a:r>
           </a:p>
           <a:p>
             <a:pPr>
               <a:spcAft>
-                <a:spcPts val="300"/>
+                <a:spcPts val="800"/>
               </a:spcAft>
             </a:pPr>
             <a:r>
-              <a:rPr sz="1300" b="0"/>
-              <a:t>J. Xu et al., “Byzantine-robust federated learning through collaborative malicious gradient filtering (SignGuard),” IEEE ICDCS, 2022.</a:t>
+              <a:rPr sz="1800" b="1"/>
+              <a:t>Acts automatically: </a:t>
+            </a:r>
+            <a:r>
+              <a:rPr sz="1800" b="0"/>
+              <a:t>detected attacker blocked on the switch, verified</a:t>
             </a:r>
           </a:p>
           <a:p>
             <a:pPr>
               <a:spcAft>
-                <a:spcPts val="300"/>
+                <a:spcPts val="800"/>
               </a:spcAft>
             </a:pPr>
             <a:r>
-              <a:rPr sz="1300" b="0"/>
-              <a:t>H. Zhang et al., “A two-stage intrusion detection method based on LightGBM and autoencoder,” Math. Biosci. Eng., vol. 20, no. 4, 2023.</a:t>
+              <a:rPr sz="1800" b="1"/>
+              <a:t>Honest data: </a:t>
+            </a:r>
+            <a:r>
+              <a:rPr sz="1800" b="0"/>
+              <a:t>found and repaired broken MITM rows; fixed a label leak first reported by Galal (2026)</a:t>
             </a:r>
           </a:p>
           <a:p>
             <a:pPr>
               <a:spcAft>
-                <a:spcPts val="300"/>
+                <a:spcPts val="800"/>
               </a:spcAft>
             </a:pPr>
             <a:r>
-              <a:rPr sz="1300" b="0"/>
-              <a:t>Z. Abou El Houda, A. S. Hafid, L. Khoukhi, “MiTFed: … federated learning using SDN and blockchain,” IEEE TNSE, vol. 10, no. 4, 2023.</a:t>
+              <a:rPr sz="1800" b="1"/>
+              <a:t>What's novel: </a:t>
+            </a:r>
+            <a:r>
+              <a:rPr sz="1800" b="0"/>
+              <a:t>we found no published system combining all five parts, and the MITM repair</a:t>
             </a:r>
           </a:p>
           <a:p>
             <a:pPr>
               <a:spcAft>
-                <a:spcPts val="300"/>
+                <a:spcPts val="800"/>
               </a:spcAft>
             </a:pPr>
             <a:r>
-              <a:rPr sz="1300" b="0"/>
-              <a:t>J. L. Hernandez-Ramos et al., “Intrusion detection based on federated learning: a systematic review,” ACM Computing Surveys, vol. 57, no. 12, 2025.</a:t>
-            </a:r>
-          </a:p>
-          <a:p>
-            <a:pPr>
-              <a:spcAft>
-                <a:spcPts val="300"/>
-              </a:spcAft>
-            </a:pPr>
-            <a:r>
-              <a:rPr sz="1300" b="0"/>
-              <a:t>I. Sharafaldin, A. H. Lashkari, A. A. Ghorbani, “Toward generating a new intrusion detection dataset and intrusion traffic characterization,” ICISSP, 2018.</a:t>
+              <a:rPr sz="1800" b="1"/>
+              <a:t>Project complete: </a:t>
+            </a:r>
+            <a:r>
+              <a:rPr sz="1800" b="0"/>
+              <a:t>every planned phase done and verified end to end; paper being written</a:t>
             </a:r>
           </a:p>
         </p:txBody>
@@ -13006,7 +12972,7 @@
           <a:p>
             <a:fld id="{840E0BF8-4B7D-46FA-B28A-DDF089F57DAF}" type="slidenum">
               <a:rPr lang="en-IN" smtClean="0"/>
-              <a:t>14</a:t>
+              <a:t>11</a:t>
             </a:fld>
             <a:endParaRPr lang="en-IN"/>
           </a:p>
@@ -13091,7 +13057,7 @@
     </p:spTree>
     <p:extLst>
       <p:ext uri="{BB962C8B-B14F-4D97-AF65-F5344CB8AC3E}">
-        <p14:creationId xmlns:p14="http://schemas.microsoft.com/office/powerpoint/2010/main" val="4097049807"/>
+        <p14:creationId xmlns:p14="http://schemas.microsoft.com/office/powerpoint/2010/main" val="586583528"/>
       </p:ext>
     </p:extLst>
   </p:cSld>
@@ -13133,7 +13099,10 @@
           <a:bodyPr/>
           <a:lstStyle/>
           <a:p>
-            <a:endParaRPr lang="en-IN" dirty="0"/>
+            <a:r>
+              <a:rPr lang="en-IN" dirty="0"/>
+              <a:t>Future Enhancements</a:t>
+            </a:r>
           </a:p>
         </p:txBody>
       </p:sp>
@@ -13149,39 +13118,73 @@
         </p:nvSpPr>
         <p:spPr/>
         <p:txBody>
-          <a:bodyPr/>
-          <a:lstStyle/>
-          <a:p>
-            <a:pPr marL="0" indent="0">
-              <a:buNone/>
+          <a:bodyPr wrap="square"/>
+          <a:lstStyle/>
+          <a:p>
+            <a:pPr>
+              <a:spcAft>
+                <a:spcPts val="1000"/>
+              </a:spcAft>
             </a:pPr>
-            <a:endParaRPr lang="en-IN" dirty="0"/>
-          </a:p>
-          <a:p>
-            <a:pPr marL="0" indent="0">
-              <a:buNone/>
+            <a:r>
+              <a:rPr sz="1900" b="0"/>
+              <a:t>Send sparse updates and test pruned models on new attacks (pruning itself is done; communication is not yet reduced)</a:t>
+            </a:r>
+            <a:endParaRPr lang="en-IN"/>
+          </a:p>
+          <a:p>
+            <a:pPr>
+              <a:spcAft>
+                <a:spcPts val="1000"/>
+              </a:spcAft>
             </a:pPr>
-            <a:endParaRPr lang="en-IN" dirty="0"/>
-          </a:p>
-          <a:p>
-            <a:pPr marL="0" indent="0">
-              <a:buNone/>
+            <a:r>
+              <a:rPr sz="1900" b="0"/>
+              <a:t>Block attacks while they are still happening (decide after the first few packets)</a:t>
+            </a:r>
+          </a:p>
+          <a:p>
+            <a:pPr>
+              <a:spcAft>
+                <a:spcPts val="1000"/>
+              </a:spcAft>
             </a:pPr>
-            <a:endParaRPr lang="en-IN" dirty="0"/>
-          </a:p>
-          <a:p>
-            <a:pPr marL="0" indent="0">
-              <a:buNone/>
+            <a:r>
+              <a:rPr sz="1900" b="0"/>
+              <a:t>Test smarter attackers, and more than 50% bad sites</a:t>
+            </a:r>
+          </a:p>
+          <a:p>
+            <a:pPr>
+              <a:spcAft>
+                <a:spcPts val="1000"/>
+              </a:spcAft>
             </a:pPr>
-            <a:endParaRPr lang="en-IN" dirty="0"/>
-          </a:p>
-          <a:p>
-            <a:pPr marL="0" indent="0" algn="ctr">
-              <a:buNone/>
+            <a:r>
+              <a:rPr sz="1900" b="0"/>
+              <a:t>Repeat every federated experiment with several seeds</a:t>
+            </a:r>
+          </a:p>
+          <a:p>
+            <a:pPr>
+              <a:spcAft>
+                <a:spcPts val="1000"/>
+              </a:spcAft>
             </a:pPr>
             <a:r>
-              <a:rPr lang="en-IN" sz="5400" dirty="0"/>
-              <a:t>Thank You</a:t>
+              <a:rPr sz="1900" b="0"/>
+              <a:t>Test on a second dataset that includes normal web traffic</a:t>
+            </a:r>
+          </a:p>
+          <a:p>
+            <a:pPr>
+              <a:spcAft>
+                <a:spcPts val="1000"/>
+              </a:spcAft>
+            </a:pPr>
+            <a:r>
+              <a:rPr sz="1900" b="0"/>
+              <a:t>Deploy on real edge devices and a hardware switch</a:t>
             </a:r>
           </a:p>
         </p:txBody>
@@ -13225,7 +13228,7 @@
           <a:p>
             <a:fld id="{840E0BF8-4B7D-46FA-B28A-DDF089F57DAF}" type="slidenum">
               <a:rPr lang="en-IN" smtClean="0"/>
-              <a:t>15</a:t>
+              <a:t>12</a:t>
             </a:fld>
             <a:endParaRPr lang="en-IN"/>
           </a:p>
@@ -13310,7 +13313,7 @@
     </p:spTree>
     <p:extLst>
       <p:ext uri="{BB962C8B-B14F-4D97-AF65-F5344CB8AC3E}">
-        <p14:creationId xmlns:p14="http://schemas.microsoft.com/office/powerpoint/2010/main" val="3778863572"/>
+        <p14:creationId xmlns:p14="http://schemas.microsoft.com/office/powerpoint/2010/main" val="3954442225"/>
       </p:ext>
     </p:extLst>
   </p:cSld>
@@ -13321,7 +13324,7 @@
 </file>
 
 <file path=ppt/slides/slide25.xml><?xml version="1.0" encoding="utf-8"?>
-<p:sld xmlns:a="http://schemas.openxmlformats.org/drawingml/2006/main" xmlns:p="http://schemas.openxmlformats.org/presentationml/2006/main" xmlns:r="http://schemas.openxmlformats.org/officeDocument/2006/relationships">
+<p:sld xmlns:a="http://schemas.openxmlformats.org/drawingml/2006/main" xmlns:r="http://schemas.openxmlformats.org/officeDocument/2006/relationships" xmlns:p="http://schemas.openxmlformats.org/presentationml/2006/main">
   <p:cSld>
     <p:spTree>
       <p:nvGrpSpPr>
@@ -13329,7 +13332,14 @@
         <p:cNvGrpSpPr/>
         <p:nvPr/>
       </p:nvGrpSpPr>
-      <p:grpSpPr/>
+      <p:grpSpPr>
+        <a:xfrm>
+          <a:off x="0" y="0"/>
+          <a:ext cx="0" cy="0"/>
+          <a:chOff x="0" y="0"/>
+          <a:chExt cx="0" cy="0"/>
+        </a:xfrm>
+      </p:grpSpPr>
       <p:sp>
         <p:nvSpPr>
           <p:cNvPr id="2" name="Title 1"/>
@@ -13346,10 +13356,71 @@
           <a:lstStyle/>
           <a:p>
             <a:r>
-              <a:rPr lang="en-US" dirty="0"/>
-              <a:t>Results: Scaling Up and Repeating</a:t>
-            </a:r>
-            <a:endParaRPr lang="en-IN" dirty="0"/>
+              <a:rPr lang="en-IN" dirty="0"/>
+              <a:t>Papers Published</a:t>
+            </a:r>
+          </a:p>
+        </p:txBody>
+      </p:sp>
+      <p:sp>
+        <p:nvSpPr>
+          <p:cNvPr id="3" name="Content Placeholder 2"/>
+          <p:cNvSpPr>
+            <a:spLocks noGrp="1"/>
+          </p:cNvSpPr>
+          <p:nvPr>
+            <p:ph idx="1"/>
+          </p:nvPr>
+        </p:nvSpPr>
+        <p:spPr/>
+        <p:txBody>
+          <a:bodyPr wrap="square"/>
+          <a:lstStyle/>
+          <a:p>
+            <a:pPr>
+              <a:spcAft>
+                <a:spcPts val="1200"/>
+              </a:spcAft>
+            </a:pPr>
+            <a:r>
+              <a:rPr sz="2000" b="1"/>
+              <a:t>Status: </a:t>
+            </a:r>
+            <a:r>
+              <a:rPr sz="2000" b="0"/>
+              <a:t>paper in preparation (draft in progress)</a:t>
+            </a:r>
+            <a:endParaRPr lang="en-IN"/>
+          </a:p>
+          <a:p>
+            <a:pPr>
+              <a:spcAft>
+                <a:spcPts val="1200"/>
+              </a:spcAft>
+            </a:pPr>
+            <a:r>
+              <a:rPr sz="2000" b="1"/>
+              <a:t>Working title: </a:t>
+            </a:r>
+            <a:r>
+              <a:rPr sz="2000" b="0"/>
+              <a:t>FL-IDS: Federated Learning-Based Intrusion Detection System for IoT/IIoT</a:t>
+            </a:r>
+          </a:p>
+          <a:p>
+            <a:pPr>
+              <a:spcAft>
+                <a:spcPts val="1200"/>
+              </a:spcAft>
+            </a:pPr>
+            <a:r>
+              <a:rPr sz="2000" b="1"/>
+              <a:t>Venue: </a:t>
+            </a:r>
+            <a:r>
+              <a:rPr sz="2000" b="0"/>
+              <a:t>not yet submitted</a:t>
+            </a:r>
           </a:p>
         </p:txBody>
       </p:sp>
@@ -13392,7 +13463,7 @@
           <a:p>
             <a:fld id="{840E0BF8-4B7D-46FA-B28A-DDF089F57DAF}" type="slidenum">
               <a:rPr lang="en-IN" smtClean="0"/>
-              <a:t>10</a:t>
+              <a:t>13</a:t>
             </a:fld>
             <a:endParaRPr lang="en-IN"/>
           </a:p>
@@ -13400,19 +13471,26 @@
       </p:sp>
       <p:pic>
         <p:nvPicPr>
-          <p:cNvPr id="6" name="Picture 5" descr="image.jpeg"/>
+          <p:cNvPr id="6" name="Picture 1"/>
           <p:cNvPicPr>
             <a:picLocks noChangeAspect="1"/>
           </p:cNvPicPr>
           <p:nvPr/>
         </p:nvPicPr>
         <p:blipFill>
-          <a:blip r:embed="rId2"/>
+          <a:blip r:embed="rId2">
+            <a:extLst>
+              <a:ext uri="{28A0092B-C50C-407E-A947-70E740481C1C}">
+                <a14:useLocalDpi xmlns:a14="http://schemas.microsoft.com/office/drawing/2010/main" val="0"/>
+              </a:ext>
+            </a:extLst>
+          </a:blip>
+          <a:srcRect/>
           <a:stretch>
             <a:fillRect/>
           </a:stretch>
         </p:blipFill>
-        <p:spPr>
+        <p:spPr bwMode="auto">
           <a:xfrm>
             <a:off x="11028362" y="19050"/>
             <a:ext cx="1163638" cy="1144588"/>
@@ -13420,124 +13498,59 @@
           <a:prstGeom prst="rect">
             <a:avLst/>
           </a:prstGeom>
-        </p:spPr>
-      </p:pic>
-      <p:sp>
-        <p:nvSpPr>
-          <p:cNvPr id="7" name="Date Placeholder 6"/>
-          <p:cNvSpPr>
-            <a:spLocks noGrp="1"/>
-          </p:cNvSpPr>
-          <p:nvPr>
-            <p:ph type="dt" sz="half" idx="10"/>
-          </p:nvPr>
-        </p:nvSpPr>
-        <p:spPr/>
-        <p:txBody>
-          <a:bodyPr/>
-          <a:lstStyle/>
-          <a:p>
-            <a:r>
-              <a:rPr lang="en-IN"/>
-              <a:t>16-10-2026</a:t>
-            </a:r>
-          </a:p>
-        </p:txBody>
-      </p:sp>
-      <p:pic>
-        <p:nvPicPr>
-          <p:cNvPr id="8" name="Picture 7" descr="image.png"/>
-          <p:cNvPicPr>
-            <a:picLocks noChangeAspect="1"/>
-          </p:cNvPicPr>
-          <p:nvPr/>
-        </p:nvPicPr>
-        <p:blipFill>
-          <a:blip r:embed="rId3"/>
-          <a:stretch>
-            <a:fillRect/>
-          </a:stretch>
-        </p:blipFill>
-        <p:spPr>
-          <a:xfrm>
-            <a:off x="2036068" y="1540688"/>
-            <a:ext cx="8119863" cy="3000000"/>
-          </a:xfrm>
-          <a:prstGeom prst="rect">
-            <a:avLst/>
-          </a:prstGeom>
-        </p:spPr>
-      </p:pic>
-      <p:sp>
-        <p:nvSpPr>
-          <p:cNvPr id="9" name="Rounded Rectangle 8"/>
-          <p:cNvSpPr/>
-          <p:nvPr/>
-        </p:nvSpPr>
-        <p:spPr>
-          <a:xfrm>
-            <a:off x="838200" y="4640688"/>
-            <a:ext cx="10515600" cy="1250000"/>
-          </a:xfrm>
-          <a:prstGeom prst="roundRect">
-            <a:avLst>
-              <a:gd name="adj" fmla="val 6000"/>
-            </a:avLst>
-          </a:prstGeom>
-          <a:solidFill>
-            <a:srgbClr val="F1F2F4"/>
-          </a:solidFill>
+          <a:noFill/>
           <a:ln>
             <a:noFill/>
           </a:ln>
-          <a:effectLst/>
-        </p:spPr>
-        <p:style>
-          <a:lnRef idx="1">
-            <a:schemeClr val="accent1"/>
-          </a:lnRef>
-          <a:fillRef idx="3">
-            <a:schemeClr val="accent1"/>
-          </a:fillRef>
-          <a:effectRef idx="2">
-            <a:schemeClr val="accent1"/>
-          </a:effectRef>
-          <a:fontRef idx="minor">
-            <a:schemeClr val="lt1"/>
-          </a:fontRef>
-        </p:style>
-        <p:txBody>
-          <a:bodyPr rtlCol="0" anchor="t" wrap="square" lIns="150000" rIns="150000" tIns="120000"/>
-          <a:lstStyle/>
-          <a:p>
-            <a:pPr algn="l"/>
-            <a:r>
-              <a:rPr sz="1500" b="1">
-                <a:solidFill>
-                  <a:srgbClr val="1E2761"/>
-                </a:solidFill>
-              </a:rPr>
-              <a:t>What it shows</a:t>
-            </a:r>
-          </a:p>
-          <a:p>
-            <a:pPr algn="l">
-              <a:spcBef>
-                <a:spcPts val="500"/>
-              </a:spcBef>
-            </a:pPr>
-            <a:r>
-              <a:rPr sz="1400" b="0">
-                <a:solidFill>
-                  <a:srgbClr val="1B1B1B"/>
-                </a:solidFill>
-              </a:rPr>
-              <a:t>Real runs, not a simulation: 10 and 20 separate client processes, three seeds each. Attacks caught on average: 0.998 with 10 sites and 0.992 with 20; false alarms stay at 2.8–4.0%. One 20-site run (seed 42) dips to 0.978 and is not yet explained.</a:t>
+          <a:extLst>
+            <a:ext uri="{909E8E84-426E-40DD-AFC4-6F175D3DCCD1}">
+              <a14:hiddenFill xmlns:a14="http://schemas.microsoft.com/office/drawing/2010/main">
+                <a:solidFill>
+                  <a:srgbClr val="FFFFFF"/>
+                </a:solidFill>
+              </a14:hiddenFill>
+            </a:ext>
+            <a:ext uri="{91240B29-F687-4F45-9708-019B960494DF}">
+              <a14:hiddenLine xmlns:a14="http://schemas.microsoft.com/office/drawing/2010/main" w="9525">
+                <a:solidFill>
+                  <a:srgbClr val="000000"/>
+                </a:solidFill>
+                <a:miter lim="800000"/>
+                <a:headEnd/>
+                <a:tailEnd/>
+              </a14:hiddenLine>
+            </a:ext>
+          </a:extLst>
+        </p:spPr>
+      </p:pic>
+      <p:sp>
+        <p:nvSpPr>
+          <p:cNvPr id="7" name="Date Placeholder 6"/>
+          <p:cNvSpPr>
+            <a:spLocks noGrp="1"/>
+          </p:cNvSpPr>
+          <p:nvPr>
+            <p:ph type="dt" sz="half" idx="10"/>
+          </p:nvPr>
+        </p:nvSpPr>
+        <p:spPr/>
+        <p:txBody>
+          <a:bodyPr/>
+          <a:lstStyle/>
+          <a:p>
+            <a:r>
+              <a:rPr lang="en-IN"/>
+              <a:t>16-10-2026</a:t>
             </a:r>
           </a:p>
         </p:txBody>
       </p:sp>
     </p:spTree>
+    <p:extLst>
+      <p:ext uri="{BB962C8B-B14F-4D97-AF65-F5344CB8AC3E}">
+        <p14:creationId xmlns:p14="http://schemas.microsoft.com/office/powerpoint/2010/main" val="3373861349"/>
+      </p:ext>
+    </p:extLst>
   </p:cSld>
   <p:clrMapOvr>
     <a:masterClrMapping/>
@@ -13546,7 +13559,7 @@
 </file>
 
 <file path=ppt/slides/slide26.xml><?xml version="1.0" encoding="utf-8"?>
-<p:sld xmlns:a="http://schemas.openxmlformats.org/drawingml/2006/main" xmlns:p="http://schemas.openxmlformats.org/presentationml/2006/main" xmlns:r="http://schemas.openxmlformats.org/officeDocument/2006/relationships">
+<p:sld xmlns:a="http://schemas.openxmlformats.org/drawingml/2006/main" xmlns:r="http://schemas.openxmlformats.org/officeDocument/2006/relationships" xmlns:p="http://schemas.openxmlformats.org/presentationml/2006/main">
   <p:cSld>
     <p:spTree>
       <p:nvGrpSpPr>
@@ -13554,7 +13567,14 @@
         <p:cNvGrpSpPr/>
         <p:nvPr/>
       </p:nvGrpSpPr>
-      <p:grpSpPr/>
+      <p:grpSpPr>
+        <a:xfrm>
+          <a:off x="0" y="0"/>
+          <a:ext cx="0" cy="0"/>
+          <a:chOff x="0" y="0"/>
+          <a:chExt cx="0" cy="0"/>
+        </a:xfrm>
+      </p:grpSpPr>
       <p:sp>
         <p:nvSpPr>
           <p:cNvPr id="2" name="Title 1"/>
@@ -13571,10 +13591,125 @@
           <a:lstStyle/>
           <a:p>
             <a:r>
-              <a:rPr lang="en-US" dirty="0"/>
-              <a:t>Results: One Whole Run, Timed</a:t>
-            </a:r>
-            <a:endParaRPr lang="en-IN" dirty="0"/>
+              <a:rPr lang="en-IN" dirty="0"/>
+              <a:t>References </a:t>
+            </a:r>
+          </a:p>
+        </p:txBody>
+      </p:sp>
+      <p:sp>
+        <p:nvSpPr>
+          <p:cNvPr id="3" name="Content Placeholder 2"/>
+          <p:cNvSpPr>
+            <a:spLocks noGrp="1"/>
+          </p:cNvSpPr>
+          <p:nvPr>
+            <p:ph idx="1"/>
+          </p:nvPr>
+        </p:nvSpPr>
+        <p:spPr/>
+        <p:txBody>
+          <a:bodyPr wrap="square"/>
+          <a:lstStyle/>
+          <a:p>
+            <a:pPr>
+              <a:spcAft>
+                <a:spcPts val="300"/>
+              </a:spcAft>
+            </a:pPr>
+            <a:r>
+              <a:rPr sz="1300" b="0"/>
+              <a:t>M. A. Ferrag et al., “Edge-IIoTset: A new comprehensive realistic cyber security dataset of IoT and IIoT applications for centralized and federated learning,” IEEE Access, vol. 10, pp. 40281–40306, 2022.</a:t>
+            </a:r>
+            <a:endParaRPr lang="en-IN"/>
+          </a:p>
+          <a:p>
+            <a:pPr>
+              <a:spcAft>
+                <a:spcPts val="300"/>
+              </a:spcAft>
+            </a:pPr>
+            <a:r>
+              <a:rPr sz="1300" b="0"/>
+              <a:t>V. Mothukuri et al., “Federated-learning-based anomaly detection for IoT security attacks,” IEEE IoT Journal, vol. 9, no. 4, 2022.</a:t>
+            </a:r>
+          </a:p>
+          <a:p>
+            <a:pPr>
+              <a:spcAft>
+                <a:spcPts val="300"/>
+              </a:spcAft>
+            </a:pPr>
+            <a:r>
+              <a:rPr sz="1300" b="0"/>
+              <a:t>B. Li et al., “DeepFed: Federated deep learning for intrusion detection in industrial cyber–physical systems,” IEEE TII, vol. 17, no. 8, 2021.</a:t>
+            </a:r>
+          </a:p>
+          <a:p>
+            <a:pPr>
+              <a:spcAft>
+                <a:spcPts val="300"/>
+              </a:spcAft>
+            </a:pPr>
+            <a:r>
+              <a:rPr sz="1300" b="0"/>
+              <a:t>X. Cao, M. Fang, J. Liu, N. Z. Gong, “FLTrust: Byzantine-robust federated learning via trust bootstrapping,” NDSS, 2021.</a:t>
+            </a:r>
+          </a:p>
+          <a:p>
+            <a:pPr>
+              <a:spcAft>
+                <a:spcPts val="300"/>
+              </a:spcAft>
+            </a:pPr>
+            <a:r>
+              <a:rPr sz="1300" b="0"/>
+              <a:t>J. Xu et al., “Byzantine-robust federated learning through collaborative malicious gradient filtering (SignGuard),” IEEE ICDCS, 2022.</a:t>
+            </a:r>
+          </a:p>
+          <a:p>
+            <a:pPr>
+              <a:spcAft>
+                <a:spcPts val="300"/>
+              </a:spcAft>
+            </a:pPr>
+            <a:r>
+              <a:rPr sz="1300" b="0"/>
+              <a:t>H. Zhang et al., “A two-stage intrusion detection method based on LightGBM and autoencoder,” Math. Biosci. Eng., vol. 20, no. 4, 2023.</a:t>
+            </a:r>
+          </a:p>
+          <a:p>
+            <a:pPr>
+              <a:spcAft>
+                <a:spcPts val="300"/>
+              </a:spcAft>
+            </a:pPr>
+            <a:r>
+              <a:rPr sz="1300" b="0"/>
+              <a:t>Z. Abou El Houda, A. S. Hafid, L. Khoukhi, “MiTFed: … federated learning using SDN and blockchain,” IEEE TNSE, vol. 10, no. 4, 2023.</a:t>
+            </a:r>
+          </a:p>
+          <a:p>
+            <a:pPr>
+              <a:spcAft>
+                <a:spcPts val="300"/>
+              </a:spcAft>
+            </a:pPr>
+            <a:r>
+              <a:rPr sz="1300" b="0"/>
+              <a:t>J. L. Hernandez-Ramos et al., “Intrusion detection based on federated learning: a systematic review,” ACM Computing Surveys, vol. 57, no. 12, 2025.</a:t>
+            </a:r>
+          </a:p>
+          <a:p>
+            <a:pPr>
+              <a:spcAft>
+                <a:spcPts val="300"/>
+              </a:spcAft>
+            </a:pPr>
+            <a:r>
+              <a:rPr sz="1300" b="0"/>
+              <a:t>I. Sharafaldin, A. H. Lashkari, A. A. Ghorbani, “Toward generating a new intrusion detection dataset and intrusion traffic characterization,” ICISSP, 2018.</a:t>
+            </a:r>
           </a:p>
         </p:txBody>
       </p:sp>
@@ -13617,7 +13752,7 @@
           <a:p>
             <a:fld id="{840E0BF8-4B7D-46FA-B28A-DDF089F57DAF}" type="slidenum">
               <a:rPr lang="en-IN" smtClean="0"/>
-              <a:t>10</a:t>
+              <a:t>14</a:t>
             </a:fld>
             <a:endParaRPr lang="en-IN"/>
           </a:p>
@@ -13625,19 +13760,26 @@
       </p:sp>
       <p:pic>
         <p:nvPicPr>
-          <p:cNvPr id="6" name="Picture 5" descr="image.jpeg"/>
+          <p:cNvPr id="6" name="Picture 1"/>
           <p:cNvPicPr>
             <a:picLocks noChangeAspect="1"/>
           </p:cNvPicPr>
           <p:nvPr/>
         </p:nvPicPr>
         <p:blipFill>
-          <a:blip r:embed="rId2"/>
+          <a:blip r:embed="rId2">
+            <a:extLst>
+              <a:ext uri="{28A0092B-C50C-407E-A947-70E740481C1C}">
+                <a14:useLocalDpi xmlns:a14="http://schemas.microsoft.com/office/drawing/2010/main" val="0"/>
+              </a:ext>
+            </a:extLst>
+          </a:blip>
+          <a:srcRect/>
           <a:stretch>
             <a:fillRect/>
           </a:stretch>
         </p:blipFill>
-        <p:spPr>
+        <p:spPr bwMode="auto">
           <a:xfrm>
             <a:off x="11028362" y="19050"/>
             <a:ext cx="1163638" cy="1144588"/>
@@ -13645,6 +13787,29 @@
           <a:prstGeom prst="rect">
             <a:avLst/>
           </a:prstGeom>
+          <a:noFill/>
+          <a:ln>
+            <a:noFill/>
+          </a:ln>
+          <a:extLst>
+            <a:ext uri="{909E8E84-426E-40DD-AFC4-6F175D3DCCD1}">
+              <a14:hiddenFill xmlns:a14="http://schemas.microsoft.com/office/drawing/2010/main">
+                <a:solidFill>
+                  <a:srgbClr val="FFFFFF"/>
+                </a:solidFill>
+              </a14:hiddenFill>
+            </a:ext>
+            <a:ext uri="{91240B29-F687-4F45-9708-019B960494DF}">
+              <a14:hiddenLine xmlns:a14="http://schemas.microsoft.com/office/drawing/2010/main" w="9525">
+                <a:solidFill>
+                  <a:srgbClr val="000000"/>
+                </a:solidFill>
+                <a:miter lim="800000"/>
+                <a:headEnd/>
+                <a:tailEnd/>
+              </a14:hiddenLine>
+            </a:ext>
+          </a:extLst>
         </p:spPr>
       </p:pic>
       <p:sp>
@@ -13669,100 +13834,231 @@
           </a:p>
         </p:txBody>
       </p:sp>
+    </p:spTree>
+    <p:extLst>
+      <p:ext uri="{BB962C8B-B14F-4D97-AF65-F5344CB8AC3E}">
+        <p14:creationId xmlns:p14="http://schemas.microsoft.com/office/powerpoint/2010/main" val="4097049807"/>
+      </p:ext>
+    </p:extLst>
+  </p:cSld>
+  <p:clrMapOvr>
+    <a:masterClrMapping/>
+  </p:clrMapOvr>
+</p:sld>
+</file>
+
+<file path=ppt/slides/slide27.xml><?xml version="1.0" encoding="utf-8"?>
+<p:sld xmlns:a="http://schemas.openxmlformats.org/drawingml/2006/main" xmlns:r="http://schemas.openxmlformats.org/officeDocument/2006/relationships" xmlns:p="http://schemas.openxmlformats.org/presentationml/2006/main">
+  <p:cSld>
+    <p:spTree>
+      <p:nvGrpSpPr>
+        <p:cNvPr id="1" name=""/>
+        <p:cNvGrpSpPr/>
+        <p:nvPr/>
+      </p:nvGrpSpPr>
+      <p:grpSpPr>
+        <a:xfrm>
+          <a:off x="0" y="0"/>
+          <a:ext cx="0" cy="0"/>
+          <a:chOff x="0" y="0"/>
+          <a:chExt cx="0" cy="0"/>
+        </a:xfrm>
+      </p:grpSpPr>
+      <p:sp>
+        <p:nvSpPr>
+          <p:cNvPr id="2" name="Title 1"/>
+          <p:cNvSpPr>
+            <a:spLocks noGrp="1"/>
+          </p:cNvSpPr>
+          <p:nvPr>
+            <p:ph type="title"/>
+          </p:nvPr>
+        </p:nvSpPr>
+        <p:spPr/>
+        <p:txBody>
+          <a:bodyPr/>
+          <a:lstStyle/>
+          <a:p>
+            <a:endParaRPr lang="en-IN" dirty="0"/>
+          </a:p>
+        </p:txBody>
+      </p:sp>
+      <p:sp>
+        <p:nvSpPr>
+          <p:cNvPr id="3" name="Content Placeholder 2"/>
+          <p:cNvSpPr>
+            <a:spLocks noGrp="1"/>
+          </p:cNvSpPr>
+          <p:nvPr>
+            <p:ph idx="1"/>
+          </p:nvPr>
+        </p:nvSpPr>
+        <p:spPr/>
+        <p:txBody>
+          <a:bodyPr/>
+          <a:lstStyle/>
+          <a:p>
+            <a:pPr marL="0" indent="0">
+              <a:buNone/>
+            </a:pPr>
+            <a:endParaRPr lang="en-IN" dirty="0"/>
+          </a:p>
+          <a:p>
+            <a:pPr marL="0" indent="0">
+              <a:buNone/>
+            </a:pPr>
+            <a:endParaRPr lang="en-IN" dirty="0"/>
+          </a:p>
+          <a:p>
+            <a:pPr marL="0" indent="0">
+              <a:buNone/>
+            </a:pPr>
+            <a:endParaRPr lang="en-IN" dirty="0"/>
+          </a:p>
+          <a:p>
+            <a:pPr marL="0" indent="0">
+              <a:buNone/>
+            </a:pPr>
+            <a:endParaRPr lang="en-IN" dirty="0"/>
+          </a:p>
+          <a:p>
+            <a:pPr marL="0" indent="0" algn="ctr">
+              <a:buNone/>
+            </a:pPr>
+            <a:r>
+              <a:rPr lang="en-IN" sz="5400" dirty="0"/>
+              <a:t>Thank You</a:t>
+            </a:r>
+          </a:p>
+        </p:txBody>
+      </p:sp>
+      <p:sp>
+        <p:nvSpPr>
+          <p:cNvPr id="4" name="Footer Placeholder 3"/>
+          <p:cNvSpPr>
+            <a:spLocks noGrp="1"/>
+          </p:cNvSpPr>
+          <p:nvPr>
+            <p:ph type="ftr" sz="quarter" idx="11"/>
+          </p:nvPr>
+        </p:nvSpPr>
+        <p:spPr/>
+        <p:txBody>
+          <a:bodyPr/>
+          <a:lstStyle/>
+          <a:p>
+            <a:r>
+              <a:rPr lang="en-IN"/>
+              <a:t>FL-IDS                         Department of CSE, BMSCE</a:t>
+            </a:r>
+          </a:p>
+        </p:txBody>
+      </p:sp>
+      <p:sp>
+        <p:nvSpPr>
+          <p:cNvPr id="5" name="Slide Number Placeholder 4"/>
+          <p:cNvSpPr>
+            <a:spLocks noGrp="1"/>
+          </p:cNvSpPr>
+          <p:nvPr>
+            <p:ph type="sldNum" sz="quarter" idx="12"/>
+          </p:nvPr>
+        </p:nvSpPr>
+        <p:spPr/>
+        <p:txBody>
+          <a:bodyPr/>
+          <a:lstStyle/>
+          <a:p>
+            <a:fld id="{840E0BF8-4B7D-46FA-B28A-DDF089F57DAF}" type="slidenum">
+              <a:rPr lang="en-IN" smtClean="0"/>
+              <a:t>15</a:t>
+            </a:fld>
+            <a:endParaRPr lang="en-IN"/>
+          </a:p>
+        </p:txBody>
+      </p:sp>
       <p:pic>
         <p:nvPicPr>
-          <p:cNvPr id="8" name="Picture 7" descr="image.png"/>
+          <p:cNvPr id="6" name="Picture 1"/>
           <p:cNvPicPr>
             <a:picLocks noChangeAspect="1"/>
           </p:cNvPicPr>
           <p:nvPr/>
         </p:nvPicPr>
         <p:blipFill>
-          <a:blip r:embed="rId3"/>
+          <a:blip r:embed="rId2">
+            <a:extLst>
+              <a:ext uri="{28A0092B-C50C-407E-A947-70E740481C1C}">
+                <a14:useLocalDpi xmlns:a14="http://schemas.microsoft.com/office/drawing/2010/main" val="0"/>
+              </a:ext>
+            </a:extLst>
+          </a:blip>
+          <a:srcRect/>
           <a:stretch>
             <a:fillRect/>
           </a:stretch>
         </p:blipFill>
-        <p:spPr>
-          <a:xfrm>
-            <a:off x="2036068" y="1540688"/>
-            <a:ext cx="8119863" cy="3000000"/>
+        <p:spPr bwMode="auto">
+          <a:xfrm>
+            <a:off x="11028362" y="19050"/>
+            <a:ext cx="1163638" cy="1144588"/>
           </a:xfrm>
           <a:prstGeom prst="rect">
             <a:avLst/>
           </a:prstGeom>
-        </p:spPr>
-      </p:pic>
-      <p:sp>
-        <p:nvSpPr>
-          <p:cNvPr id="9" name="Rounded Rectangle 8"/>
-          <p:cNvSpPr/>
-          <p:nvPr/>
-        </p:nvSpPr>
-        <p:spPr>
-          <a:xfrm>
-            <a:off x="838200" y="4640688"/>
-            <a:ext cx="10515600" cy="1250000"/>
-          </a:xfrm>
-          <a:prstGeom prst="roundRect">
-            <a:avLst>
-              <a:gd name="adj" fmla="val 6000"/>
-            </a:avLst>
-          </a:prstGeom>
-          <a:solidFill>
-            <a:srgbClr val="F1F2F4"/>
-          </a:solidFill>
+          <a:noFill/>
           <a:ln>
             <a:noFill/>
           </a:ln>
-          <a:effectLst/>
-        </p:spPr>
-        <p:style>
-          <a:lnRef idx="1">
-            <a:schemeClr val="accent1"/>
-          </a:lnRef>
-          <a:fillRef idx="3">
-            <a:schemeClr val="accent1"/>
-          </a:fillRef>
-          <a:effectRef idx="2">
-            <a:schemeClr val="accent1"/>
-          </a:effectRef>
-          <a:fontRef idx="minor">
-            <a:schemeClr val="lt1"/>
-          </a:fontRef>
-        </p:style>
-        <p:txBody>
-          <a:bodyPr rtlCol="0" anchor="t" wrap="square" lIns="150000" rIns="150000" tIns="120000"/>
-          <a:lstStyle/>
-          <a:p>
-            <a:pPr algn="l"/>
-            <a:r>
-              <a:rPr sz="1500" b="1">
-                <a:solidFill>
-                  <a:srgbClr val="1E2761"/>
-                </a:solidFill>
-              </a:rPr>
-              <a:t>What it shows</a:t>
-            </a:r>
-          </a:p>
-          <a:p>
-            <a:pPr algn="l">
-              <a:spcBef>
-                <a:spcPts val="500"/>
-              </a:spcBef>
-            </a:pPr>
-            <a:r>
-              <a:rPr sz="1400" b="0">
-                <a:solidFill>
-                  <a:srgbClr val="1B1B1B"/>
-                </a:solidFill>
-              </a:rPr>
-              <a:t>A complete run, from raw data to a block rule on the switch, took about 219 seconds. Training the shared model is almost all of it; once a model exists, spotting and blocking an attack takes seconds.</a:t>
+          <a:extLst>
+            <a:ext uri="{909E8E84-426E-40DD-AFC4-6F175D3DCCD1}">
+              <a14:hiddenFill xmlns:a14="http://schemas.microsoft.com/office/drawing/2010/main">
+                <a:solidFill>
+                  <a:srgbClr val="FFFFFF"/>
+                </a:solidFill>
+              </a14:hiddenFill>
+            </a:ext>
+            <a:ext uri="{91240B29-F687-4F45-9708-019B960494DF}">
+              <a14:hiddenLine xmlns:a14="http://schemas.microsoft.com/office/drawing/2010/main" w="9525">
+                <a:solidFill>
+                  <a:srgbClr val="000000"/>
+                </a:solidFill>
+                <a:miter lim="800000"/>
+                <a:headEnd/>
+                <a:tailEnd/>
+              </a14:hiddenLine>
+            </a:ext>
+          </a:extLst>
+        </p:spPr>
+      </p:pic>
+      <p:sp>
+        <p:nvSpPr>
+          <p:cNvPr id="7" name="Date Placeholder 6"/>
+          <p:cNvSpPr>
+            <a:spLocks noGrp="1"/>
+          </p:cNvSpPr>
+          <p:nvPr>
+            <p:ph type="dt" sz="half" idx="10"/>
+          </p:nvPr>
+        </p:nvSpPr>
+        <p:spPr/>
+        <p:txBody>
+          <a:bodyPr/>
+          <a:lstStyle/>
+          <a:p>
+            <a:r>
+              <a:rPr lang="en-IN"/>
+              <a:t>16-10-2026</a:t>
             </a:r>
           </a:p>
         </p:txBody>
       </p:sp>
     </p:spTree>
+    <p:extLst>
+      <p:ext uri="{BB962C8B-B14F-4D97-AF65-F5344CB8AC3E}">
+        <p14:creationId xmlns:p14="http://schemas.microsoft.com/office/powerpoint/2010/main" val="3778863572"/>
+      </p:ext>
+    </p:extLst>
   </p:cSld>
   <p:clrMapOvr>
     <a:masterClrMapping/>

</xml_diff>

<commit_message>
Full pool, split by connection: the whole federated system on all 1.99M usable rows
- Connection ids in the feature cache; connection-grouped calibration split, client partition and train/val/test split (data.group_by_flow), with tests
- Client-side boosting-filter cache per model version (identical results, about 5x faster rounds)
- Six real multi-process Phase A runs (10 and 20 clients, seeds 42-44), connection-level false-alarm analysis, per-class breakdowns
- 77 in-process jobs: poisoning sweep, ablation, zero-day (all rows of each held-out class), stealth attacker, pruning, clip
- Phase B on all 14 attack captures; tolerate the damaged Vulnerability-scanner capture
- PAPER_NOTES 8.15, results page 7d, report section, new slide, regenerated explainers; the 60k-pool results are kept as the comparison
- 244 tests pass, 1 skipped

Co-Authored-By: Claude Sonnet 5.5 <noreply@anthropic.com>
</commit_message>
<xml_diff>
--- a/deliverables/presentation/FL-IDS_Review_Presentation.pptx
+++ b/deliverables/presentation/FL-IDS_Review_Presentation.pptx
@@ -29,6 +29,7 @@
     <p:sldId id="284" r:id="rId4"/>
     <p:sldId id="278" r:id="rId26"/>
     <p:sldId id="285" r:id="rId32"/>
+    <p:sldId id="287" r:id="rId34"/>
     <p:sldId id="286" r:id="rId33"/>
     <p:sldId id="271" r:id="rId12"/>
     <p:sldId id="270" r:id="rId13"/>
@@ -832,7 +833,7 @@
           <a:lstStyle/>
           <a:p>
             <a:r>
-              <a:t>The dataset is Edge-IIoTset: about two million packets after cleaning, fifteen classes, 71% normal traffic. The classifier is trained on 1.43 million of them and tested on 397 thousand it never saw. The federated part uses a smaller share, about 125 thousand rows, so that the 150 or so experiment runs finish in time. We test strictly, on whole connections never seen in training, and repeat with three seeds. Before any of this we fixed two errors in the public data. One was a formatting difference that alone separated normal from attack traffic perfectly; Galal reported it first, in August 2026, and we credit that paper. The other, MITM rows stored under the wrong column names, we found and repaired ourselves.</a:t>
+              <a:t>The dataset is Edge-IIoTset: about two million packets after cleaning, fifteen classes, 71% normal traffic. The classifier is trained on 1.43 million of them and tested on 397 thousand it never saw. The federated part first ran on a 60 thousand row sample; the main results now use the whole pool, about 1.89 million rows, with each conversation kept together. We test strictly, on whole connections never seen in training, and repeat with three seeds. Before any of this we fixed two errors in the public data. One was a formatting difference that alone separated normal from attack traffic perfectly; Galal reported it first, in August 2026, and we credit that paper. The other, MITM rows stored under the wrong column names, we found and repaired ourselves.</a:t>
             </a:r>
           </a:p>
         </p:txBody>
@@ -1813,6 +1814,76 @@
           <a:p>
             <a:r>
               <a:t>Three follow-ups. First, weight pruning, which was one of our objectives: pruned while the shared model trains, 70 percent of the weights can go and the backstop barely changes; pruned afterwards it collapses. Second, a smarter attacker that knows how our filter works: it gets through most of the time, which is a real weakness, although the first-stage classifier still catches known attacks. Third, we repeated the big experiments with two more seeds and the conclusions held. Limits: single seed for pruning and the smart attacker, and we did not test new-attack detection against the smart attacker.</a:t>
+            </a:r>
+          </a:p>
+        </p:txBody>
+      </p:sp>
+      <p:sp>
+        <p:nvSpPr>
+          <p:cNvPr id="4" name="Slide Number Placeholder 3"/>
+          <p:cNvSpPr>
+            <a:spLocks noGrp="1"/>
+          </p:cNvSpPr>
+          <p:nvPr>
+            <p:ph type="sldNum" idx="5" sz="quarter"/>
+          </p:nvPr>
+        </p:nvSpPr>
+        <p:spPr/>
+      </p:sp>
+    </p:spTree>
+  </p:cSld>
+  <p:clrMapOvr>
+    <a:masterClrMapping/>
+  </p:clrMapOvr>
+</p:notes>
+</file>
+
+<file path=ppt/notesSlides/notesSlide27.xml><?xml version="1.0" encoding="utf-8"?>
+<p:notes xmlns:a="http://schemas.openxmlformats.org/drawingml/2006/main" xmlns:p="http://schemas.openxmlformats.org/presentationml/2006/main" xmlns:r="http://schemas.openxmlformats.org/officeDocument/2006/relationships">
+  <p:cSld>
+    <p:spTree>
+      <p:nvGrpSpPr>
+        <p:cNvPr id="1" name=""/>
+        <p:cNvGrpSpPr/>
+        <p:nvPr/>
+      </p:nvGrpSpPr>
+      <p:grpSpPr>
+        <a:xfrm>
+          <a:off x="0" y="0"/>
+          <a:ext cx="0" cy="0"/>
+          <a:chOff x="0" y="0"/>
+          <a:chExt cx="0" cy="0"/>
+        </a:xfrm>
+      </p:grpSpPr>
+      <p:sp>
+        <p:nvSpPr>
+          <p:cNvPr id="2" name="Slide Image Placeholder 1"/>
+          <p:cNvSpPr>
+            <a:spLocks noGrp="1"/>
+          </p:cNvSpPr>
+          <p:nvPr>
+            <p:ph type="sldImg" idx="2"/>
+          </p:nvPr>
+        </p:nvSpPr>
+        <p:spPr/>
+      </p:sp>
+      <p:sp>
+        <p:nvSpPr>
+          <p:cNvPr id="3" name="Notes Placeholder 2"/>
+          <p:cNvSpPr>
+            <a:spLocks noGrp="1"/>
+          </p:cNvSpPr>
+          <p:nvPr>
+            <p:ph type="body" idx="3" sz="quarter"/>
+          </p:nvPr>
+        </p:nvSpPr>
+        <p:spPr/>
+        <p:txBody>
+          <a:bodyPr/>
+          <a:lstStyle/>
+          <a:p>
+            <a:r>
+              <a:t>This is the run you asked about: the whole federated system on the whole dataset, six real runs with 10 and 20 sites, three seeds. We also made the test stricter: all packets of one conversation stay together, so a test packet never has a twin in the practice data. Known attacks are caught as before, so nothing was inflated. False alarms depend on how you count: per packet some runs flag up to 16 percent of normal packets, but that is a handful of very long normal conversations being flagged as a block; per conversation it is under one percent. New-attack detection and the trust filter are somewhat weaker at this scale and we do not yet know why. In the live demo all 14 recorded attacks were blocked; two were labelled as the wrong attack type (the MITM recording as Ransomware, the fingerprinting recording as DDoS). These are the dataset's own recordings, so it is a demonstration, not a held-out test.</a:t>
             </a:r>
           </a:p>
         </p:txBody>
@@ -14059,6 +14130,231 @@
         <p14:creationId xmlns:p14="http://schemas.microsoft.com/office/powerpoint/2010/main" val="3778863572"/>
       </p:ext>
     </p:extLst>
+  </p:cSld>
+  <p:clrMapOvr>
+    <a:masterClrMapping/>
+  </p:clrMapOvr>
+</p:sld>
+</file>
+
+<file path=ppt/slides/slide28.xml><?xml version="1.0" encoding="utf-8"?>
+<p:sld xmlns:a="http://schemas.openxmlformats.org/drawingml/2006/main" xmlns:p="http://schemas.openxmlformats.org/presentationml/2006/main" xmlns:r="http://schemas.openxmlformats.org/officeDocument/2006/relationships">
+  <p:cSld>
+    <p:spTree>
+      <p:nvGrpSpPr>
+        <p:cNvPr id="1" name=""/>
+        <p:cNvGrpSpPr/>
+        <p:nvPr/>
+      </p:nvGrpSpPr>
+      <p:grpSpPr/>
+      <p:sp>
+        <p:nvSpPr>
+          <p:cNvPr id="2" name="Title 1"/>
+          <p:cNvSpPr>
+            <a:spLocks noGrp="1"/>
+          </p:cNvSpPr>
+          <p:nvPr>
+            <p:ph type="title"/>
+          </p:nvPr>
+        </p:nvSpPr>
+        <p:spPr/>
+        <p:txBody>
+          <a:bodyPr/>
+          <a:lstStyle/>
+          <a:p>
+            <a:r>
+              <a:rPr lang="en-US" dirty="0"/>
+              <a:t>Results: The Whole Dataset</a:t>
+            </a:r>
+            <a:endParaRPr lang="en-IN" dirty="0"/>
+          </a:p>
+        </p:txBody>
+      </p:sp>
+      <p:sp>
+        <p:nvSpPr>
+          <p:cNvPr id="4" name="Footer Placeholder 3"/>
+          <p:cNvSpPr>
+            <a:spLocks noGrp="1"/>
+          </p:cNvSpPr>
+          <p:nvPr>
+            <p:ph type="ftr" sz="quarter" idx="11"/>
+          </p:nvPr>
+        </p:nvSpPr>
+        <p:spPr/>
+        <p:txBody>
+          <a:bodyPr/>
+          <a:lstStyle/>
+          <a:p>
+            <a:r>
+              <a:rPr lang="en-IN"/>
+              <a:t>FL-IDS                         Department of CSE, BMSCE</a:t>
+            </a:r>
+          </a:p>
+        </p:txBody>
+      </p:sp>
+      <p:sp>
+        <p:nvSpPr>
+          <p:cNvPr id="5" name="Slide Number Placeholder 4"/>
+          <p:cNvSpPr>
+            <a:spLocks noGrp="1"/>
+          </p:cNvSpPr>
+          <p:nvPr>
+            <p:ph type="sldNum" sz="quarter" idx="12"/>
+          </p:nvPr>
+        </p:nvSpPr>
+        <p:spPr/>
+        <p:txBody>
+          <a:bodyPr/>
+          <a:lstStyle/>
+          <a:p>
+            <a:fld id="{840E0BF8-4B7D-46FA-B28A-DDF089F57DAF}" type="slidenum">
+              <a:rPr lang="en-IN" smtClean="0"/>
+              <a:t>10</a:t>
+            </a:fld>
+            <a:endParaRPr lang="en-IN"/>
+          </a:p>
+        </p:txBody>
+      </p:sp>
+      <p:pic>
+        <p:nvPicPr>
+          <p:cNvPr id="6" name="Picture 5" descr="image.jpeg"/>
+          <p:cNvPicPr>
+            <a:picLocks noChangeAspect="1"/>
+          </p:cNvPicPr>
+          <p:nvPr/>
+        </p:nvPicPr>
+        <p:blipFill>
+          <a:blip r:embed="rId2"/>
+          <a:stretch>
+            <a:fillRect/>
+          </a:stretch>
+        </p:blipFill>
+        <p:spPr>
+          <a:xfrm>
+            <a:off x="11028362" y="19050"/>
+            <a:ext cx="1163638" cy="1144588"/>
+          </a:xfrm>
+          <a:prstGeom prst="rect">
+            <a:avLst/>
+          </a:prstGeom>
+        </p:spPr>
+      </p:pic>
+      <p:sp>
+        <p:nvSpPr>
+          <p:cNvPr id="7" name="Date Placeholder 6"/>
+          <p:cNvSpPr>
+            <a:spLocks noGrp="1"/>
+          </p:cNvSpPr>
+          <p:nvPr>
+            <p:ph type="dt" sz="half" idx="10"/>
+          </p:nvPr>
+        </p:nvSpPr>
+        <p:spPr/>
+        <p:txBody>
+          <a:bodyPr/>
+          <a:lstStyle/>
+          <a:p>
+            <a:r>
+              <a:rPr lang="en-IN"/>
+              <a:t>16-10-2026</a:t>
+            </a:r>
+          </a:p>
+        </p:txBody>
+      </p:sp>
+      <p:pic>
+        <p:nvPicPr>
+          <p:cNvPr id="8" name="Picture 7" descr="image.png"/>
+          <p:cNvPicPr>
+            <a:picLocks noChangeAspect="1"/>
+          </p:cNvPicPr>
+          <p:nvPr/>
+        </p:nvPicPr>
+        <p:blipFill>
+          <a:blip r:embed="rId3"/>
+          <a:stretch>
+            <a:fillRect/>
+          </a:stretch>
+        </p:blipFill>
+        <p:spPr>
+          <a:xfrm>
+            <a:off x="1436068" y="1540688"/>
+            <a:ext cx="9319863" cy="3000000"/>
+          </a:xfrm>
+          <a:prstGeom prst="rect">
+            <a:avLst/>
+          </a:prstGeom>
+        </p:spPr>
+      </p:pic>
+      <p:sp>
+        <p:nvSpPr>
+          <p:cNvPr id="9" name="Rounded Rectangle 8"/>
+          <p:cNvSpPr/>
+          <p:nvPr/>
+        </p:nvSpPr>
+        <p:spPr>
+          <a:xfrm>
+            <a:off x="838200" y="4640688"/>
+            <a:ext cx="10515600" cy="1250000"/>
+          </a:xfrm>
+          <a:prstGeom prst="roundRect">
+            <a:avLst>
+              <a:gd name="adj" fmla="val 6000"/>
+            </a:avLst>
+          </a:prstGeom>
+          <a:solidFill>
+            <a:srgbClr val="F1F2F4"/>
+          </a:solidFill>
+          <a:ln>
+            <a:noFill/>
+          </a:ln>
+          <a:effectLst/>
+        </p:spPr>
+        <p:style>
+          <a:lnRef idx="1">
+            <a:schemeClr val="accent1"/>
+          </a:lnRef>
+          <a:fillRef idx="3">
+            <a:schemeClr val="accent1"/>
+          </a:fillRef>
+          <a:effectRef idx="2">
+            <a:schemeClr val="accent1"/>
+          </a:effectRef>
+          <a:fontRef idx="minor">
+            <a:schemeClr val="lt1"/>
+          </a:fontRef>
+        </p:style>
+        <p:txBody>
+          <a:bodyPr rtlCol="0" anchor="t" wrap="square" lIns="150000" rIns="150000" tIns="120000"/>
+          <a:lstStyle/>
+          <a:p>
+            <a:pPr algn="l"/>
+            <a:r>
+              <a:rPr sz="1500" b="1">
+                <a:solidFill>
+                  <a:srgbClr val="1E2761"/>
+                </a:solidFill>
+              </a:rPr>
+              <a:t>What it shows</a:t>
+            </a:r>
+          </a:p>
+          <a:p>
+            <a:pPr algn="l">
+              <a:spcBef>
+                <a:spcPts val="500"/>
+              </a:spcBef>
+            </a:pPr>
+            <a:r>
+              <a:rPr sz="1400" b="0">
+                <a:solidFill>
+                  <a:srgbClr val="1B1B1B"/>
+                </a:solidFill>
+              </a:rPr>
+              <a:t>Everything now trains on all 1.99 million usable messages, with each conversation kept on one side of the exam. Known attacks: still 99.6% caught. False alarms: about 3% for a typical site, up to 16% of all normal packets, because a few very long normal conversations get flagged (under 1% of conversations). New attacks: 90–94% detected (was 94–95%). All 14 recorded attacks are blocked in the live demo; 12 are named correctly.</a:t>
+            </a:r>
+          </a:p>
+        </p:txBody>
+      </p:sp>
+    </p:spTree>
   </p:cSld>
   <p:clrMapOvr>
     <a:masterClrMapping/>

</xml_diff>